<commit_message>
Move one slide past the end to shorten length
Shorten length by taking out one slide
</commit_message>
<xml_diff>
--- a/Week16-FinalProjects/Cathy-FinalPrezDocScenario.pptx
+++ b/Week16-FinalProjects/Cathy-FinalPrezDocScenario.pptx
@@ -11,13 +11,13 @@
     <p:sldId id="256" r:id="rId2"/>
     <p:sldId id="258" r:id="rId3"/>
     <p:sldId id="263" r:id="rId4"/>
-    <p:sldId id="266" r:id="rId5"/>
-    <p:sldId id="264" r:id="rId6"/>
-    <p:sldId id="259" r:id="rId7"/>
-    <p:sldId id="260" r:id="rId8"/>
-    <p:sldId id="262" r:id="rId9"/>
-    <p:sldId id="265" r:id="rId10"/>
-    <p:sldId id="267" r:id="rId11"/>
+    <p:sldId id="264" r:id="rId5"/>
+    <p:sldId id="259" r:id="rId6"/>
+    <p:sldId id="260" r:id="rId7"/>
+    <p:sldId id="262" r:id="rId8"/>
+    <p:sldId id="265" r:id="rId9"/>
+    <p:sldId id="267" r:id="rId10"/>
+    <p:sldId id="266" r:id="rId11"/>
   </p:sldIdLst>
   <p:sldSz cx="12192000" cy="6858000"/>
   <p:notesSz cx="6858000" cy="9144000"/>
@@ -131,6 +131,9 @@
         </p15:guide>
       </p15:sldGuideLst>
     </p:ext>
+    <p:ext uri="{2D200454-40CA-4A62-9FC3-DE9A4176ACB9}">
+      <p15:notesGuideLst xmlns:p15="http://schemas.microsoft.com/office/powerpoint/2012/main"/>
+    </p:ext>
   </p:extLst>
 </p:presentation>
 </file>
@@ -217,7 +220,7 @@
           <a:p>
             <a:fld id="{318CEF18-6B58-49E8-ACE9-9DF04598EFDF}" type="datetimeFigureOut">
               <a:rPr lang="en-US" smtClean="0"/>
-              <a:t>4/22/2026</a:t>
+              <a:t>5/7/2026</a:t>
             </a:fld>
             <a:endParaRPr lang="en-US"/>
           </a:p>
@@ -642,40 +645,8 @@
           <a:p>
             <a:r>
               <a:rPr lang="en-US"/>
-              <a:t>I’ve enjoyed learning alongside you all. I wish you all the best in your tech writing careers. </a:t>
-            </a:r>
-          </a:p>
-          <a:p>
-            <a:r>
-              <a:rPr lang="en-US"/>
-              <a:t>Zoe, thank you so much for introducing us to everything we’ve covered these past 15 weeks. I’m going to put some of this information to use in my job fairly quickly, so this course has absolutely been very useful, and I’m grateful for your willingness to share your expertise. </a:t>
-            </a:r>
-          </a:p>
-          <a:p>
-            <a:pPr marL="0" marR="0" lvl="0" indent="0" algn="l" defTabSz="914400" rtl="0" eaLnBrk="1" fontAlgn="auto" latinLnBrk="0" hangingPunct="1">
-              <a:lnSpc>
-                <a:spcPct val="100000"/>
-              </a:lnSpc>
-              <a:spcBef>
-                <a:spcPts val="0"/>
-              </a:spcBef>
-              <a:spcAft>
-                <a:spcPts val="0"/>
-              </a:spcAft>
-              <a:buClrTx/>
-              <a:buSzTx/>
-              <a:buFontTx/>
-              <a:buNone/>
-              <a:tabLst/>
-              <a:defRPr/>
-            </a:pPr>
-            <a:r>
-              <a:rPr lang="en-US"/>
-              <a:t>Any questions?</a:t>
-            </a:r>
-          </a:p>
-          <a:p>
-            <a:endParaRPr lang="en-US"/>
+              <a:t>Because the US runs on small businesses. All the information on this slide is taken from the US Chamber of Commerce’s website, on the Small Business Data Center page. The rest of what’s on that web page is eye-opening, as far as how small businesses drive our economy. Small businesses employ almost half the American workforce, and produce almost half of the nation’s gross domestic output. Take a look at the dollar figures I underlined in the lower left quote: in 2014, small businesses generated almost 5.9 TRILLION dollars of the national GDP. Large businesses generated 7.7 trillion. </a:t>
+            </a:r>
           </a:p>
         </p:txBody>
       </p:sp>
@@ -705,7 +676,7 @@
     </p:spTree>
     <p:extLst>
       <p:ext uri="{BB962C8B-B14F-4D97-AF65-F5344CB8AC3E}">
-        <p14:creationId xmlns:p14="http://schemas.microsoft.com/office/powerpoint/2010/main" val="330846222"/>
+        <p14:creationId xmlns:p14="http://schemas.microsoft.com/office/powerpoint/2010/main" val="2560666280"/>
       </p:ext>
     </p:extLst>
   </p:cSld>
@@ -778,7 +749,7 @@
             </a:pPr>
             <a:r>
               <a:rPr lang="en-US"/>
-              <a:t>A little bit about me: I’m a software engineer. Been in the industry for a long time! I have helped develop commercial software and I’ve worked at several government contractors, which includes the company where I work now. Before Agile, writing was a good part of an engineer’s job, although usually the audience was other engineers. I have  also sometimes written user documentation. </a:t>
+              <a:t>A little bit about me: I’m a software engineer. Been in the industry for a long time! I have helped develop commercial software and I’ve worked at several government contractors, including the company where I work now. Before Agile, writing was a good part of an engineer’s job, although usually the audience was other engineers. I have also sometimes written user documentation. </a:t>
             </a:r>
           </a:p>
           <a:p>
@@ -801,7 +772,7 @@
             </a:pPr>
             <a:r>
               <a:rPr lang="en-US"/>
-              <a:t>What hat(s) I wear is dependent on the size of company and what we’re producing. The two largest companies I’ve worked for were both over 100,000 employees worldwide. The smallest place I worked started out with six people, and at the end, there were two of us. Those smaller companies are where I’ve sometimes worn a hat as a tech writer, in addition to writing code. </a:t>
+              <a:t>What hat(s) I wear is dependent on the size of company and what we’re producing. The two largest companies I’ve worked for both had over 100,000 employees worldwide. The smallest place I worked had two. Those smaller companies are where I’ve sometimes worn a hat as a tech writer, in addition to writing code. </a:t>
             </a:r>
           </a:p>
           <a:p>
@@ -830,7 +801,7 @@
             </a:pPr>
             <a:r>
               <a:rPr lang="en-US"/>
-              <a:t>There was too much text here -- I wanted to put in a picture, so I’ll mention the set of user documentation I’ve been working on most recently; it includes a 50+pg operator manual, a 30pg user interface guide, a 6 page UI quick reference guide, and a week or so ago I turned the quick reference into a 4”x6” laminated flip book. We put that onto a key ring on a zip reel, with a carabiner to hook onto anything handy when users are out in the field (and I do mean – REALLY out in a field).</a:t>
+              <a:t>There was too much text on this slide -- I wanted to put in a picture, so I’ll mention the set of user documentation I’ve been working on most recently; it includes a 50+pg operator manual, a 30pg user interface guide, a 10 page UI quick reference guide, and a week or so ago I turned the quick reference into a 4”x6” laminated flip book. We put that onto a key ring on a zip reel, with a carabiner to hook onto anything handy when users are out in the field (and I do mean – REALLY out in a field).</a:t>
             </a:r>
           </a:p>
         </p:txBody>
@@ -934,13 +905,13 @@
           <a:p>
             <a:r>
               <a:rPr lang="en-US"/>
-              <a:t>A lot of high tech, medical, and biotech research starts in academic institutions, then moves to startups with their inventors; hopefully those grow and further develop their tech to the point of receiving venture capital investment, and then move to commercialization. SBIR grants help businesses with money to get from their very early stages of development to VC investment and/or productization.</a:t>
-            </a:r>
-          </a:p>
-          <a:p>
-            <a:r>
-              <a:rPr lang="en-US"/>
-              <a:t>The SBIR Act is still going strong after 44 years; according to my congressional representative, it’s considered one of the most successful pieces of legislation in US history.</a:t>
+              <a:t>A lot of high tech, medical, and biotech research starts in academic institutions, then moves to startups with their inventors; hopefully those grow and further develop their tech to the point of receiving venture capital investment, and then move to commercialization. SBIR grants help businesses with money to get from their very early stages of development, to VC investment and/or productization.</a:t>
+            </a:r>
+          </a:p>
+          <a:p>
+            <a:r>
+              <a:rPr lang="en-US"/>
+              <a:t>The SBIR Act is still going strong after 44 years. According to my congressional representative, it’s considered one of the most successful pieces of legislation in US history.</a:t>
             </a:r>
           </a:p>
           <a:p>
@@ -1033,7 +1004,19 @@
           <a:p>
             <a:r>
               <a:rPr lang="en-US"/>
-              <a:t>Because the US runs on small businesses. All the information on this slide is taken from the US Chamber of Commerce’s website, on the Small Business Data Center page. The rest of what’s on that page is eye-opening, as far as how small businesses drive our economy. Small businesses employ almost half the American workforce, and produce almost half of the nation’s gross domestic output. Take a look at the dollar figures I underlined in the lower left quote: in 2014, small businesses generated almost 5.9 TRILLION dollars of the national GDP. Large businesses generated 7.7 trillion. </a:t>
+              <a:t>I took these graphics directly from the SBIR website. The Department of Defense has the biggest research budget of all the fed agencies; there is a TREMENDOUS amount of our current everyday technology that originated from the DoD, including microwave ovens, GPS, and drones. One of the requirements when proposing DoD SBIR research is that there must be what’s called a “dual-use” capability – a commercial need and market for what is being researched and prototyped. </a:t>
+            </a:r>
+          </a:p>
+          <a:p>
+            <a:r>
+              <a:rPr lang="en-US"/>
+              <a:t>The second biggest budget comes from Health and Human Services, for medical and biotech research; they fund the CDC, FDA, and NIH.</a:t>
+            </a:r>
+          </a:p>
+          <a:p>
+            <a:r>
+              <a:rPr lang="en-US"/>
+              <a:t>There is a proposal and evaluation process, and there are a number of stages to go through in developing whatever your prototype or product is. It is not quite as simple as the lower graphic illustrates. At my current company, the software we’re developing started from a Phase I SBIR ($250K for six months, although it can vary w/organization), and has gone through multiple Phase II, Phase III, and BAA awards, over the course of more than 11 years and $20 million. Right now, we have a core group of four people working on it, with at least 15-20 more who’ve come and gone over my 9 years, and that does not count people loaned from other groups in our company or summer interns.</a:t>
             </a:r>
           </a:p>
         </p:txBody>
@@ -1064,7 +1047,7 @@
     </p:spTree>
     <p:extLst>
       <p:ext uri="{BB962C8B-B14F-4D97-AF65-F5344CB8AC3E}">
-        <p14:creationId xmlns:p14="http://schemas.microsoft.com/office/powerpoint/2010/main" val="2560666280"/>
+        <p14:creationId xmlns:p14="http://schemas.microsoft.com/office/powerpoint/2010/main" val="3349370701"/>
       </p:ext>
     </p:extLst>
   </p:cSld>
@@ -1120,19 +1103,47 @@
           <a:p>
             <a:r>
               <a:rPr lang="en-US"/>
-              <a:t>I took these graphics directly from the SBIR website. The Department of Defense has the biggest research budget of all the fed agencies; there is a TREMENDOUS amount of our current everyday technology that originated from the DoD, including microwave ovens, GPS, and drones. One of the requirements when proposing DoD SBIR research is that there must be what’s called a “dual-use” capability – a commercial need and market for what is being researched and prototyped. </a:t>
-            </a:r>
-          </a:p>
-          <a:p>
-            <a:r>
-              <a:rPr lang="en-US"/>
-              <a:t>The second biggest budget comes from Health and Human Services, for medical and biotech research; they fund the CDC, FDA, and NIH.</a:t>
-            </a:r>
-          </a:p>
-          <a:p>
-            <a:r>
-              <a:rPr lang="en-US"/>
-              <a:t>There is a proposal and evaluation process, and there are a number of stages to go through in developing whatever your prototype or product is. It is not quite as simple as the lower graphic illustrates. At my current company, the software we’re developing started from a Phase I SBIR ($250K for six months, although it can vary w/organization), and has gone through multiple Phase II, Phase III, and BAA awards, over the course of more than 11 years and $20 million. Right now, we have a core group of four people working on it, with at least 15-20 more who’ve come and gone over my 9 years, and that does not count people loaned from other groups in our company or summer interns.</a:t>
+              <a:t>So here’s my real-life documentation scenario.</a:t>
+            </a:r>
+          </a:p>
+          <a:p>
+            <a:r>
+              <a:rPr lang="en-US"/>
+              <a:t>We are a small company, roughly 100 people. Up until the past 10-12 years, we’ve done mainly SBIRs, but management started to realize that that was not a sustainable way to grow the company. We’ve been pushing for awhile to turn some of our longest-running programs into actual saleable software products. </a:t>
+            </a:r>
+          </a:p>
+          <a:p>
+            <a:r>
+              <a:rPr lang="en-US"/>
+              <a:t>We do a lot with </a:t>
+            </a:r>
+            <a:r>
+              <a:rPr lang="en-US" sz="1200" b="0" i="0" kern="1200">
+                <a:solidFill>
+                  <a:schemeClr val="tx1"/>
+                </a:solidFill>
+                <a:effectLst/>
+                <a:latin typeface="+mn-lt"/>
+                <a:ea typeface="+mn-ea"/>
+                <a:cs typeface="+mn-cs"/>
+              </a:rPr>
+              <a:t>computer vision, with estimation and optimization algorithms; </a:t>
+            </a:r>
+            <a:r>
+              <a:rPr lang="en-US"/>
+              <a:t>a lot of modeling and simulation. </a:t>
+            </a:r>
+          </a:p>
+          <a:p>
+            <a:r>
+              <a:rPr lang="en-US"/>
+              <a:t>We once partnered with a university to design and test a new shape for an airplane wing. (I didn’t see the wing, but the project lead asked me to review the manual and give some feedback.)</a:t>
+            </a:r>
+          </a:p>
+          <a:p>
+            <a:r>
+              <a:rPr lang="en-US"/>
+              <a:t>We’ve worked on developing aircraft collision avoidance systems and non-GPS navigation.</a:t>
             </a:r>
           </a:p>
         </p:txBody>
@@ -1163,7 +1174,7 @@
     </p:spTree>
     <p:extLst>
       <p:ext uri="{BB962C8B-B14F-4D97-AF65-F5344CB8AC3E}">
-        <p14:creationId xmlns:p14="http://schemas.microsoft.com/office/powerpoint/2010/main" val="3349370701"/>
+        <p14:creationId xmlns:p14="http://schemas.microsoft.com/office/powerpoint/2010/main" val="3235356827"/>
       </p:ext>
     </p:extLst>
   </p:cSld>
@@ -1219,47 +1230,43 @@
           <a:p>
             <a:r>
               <a:rPr lang="en-US"/>
-              <a:t>So here’s my real-life documentation scenario.</a:t>
-            </a:r>
-          </a:p>
-          <a:p>
-            <a:r>
-              <a:rPr lang="en-US"/>
-              <a:t>We are a small company, roughly 100 people. Up until the past 10-12 years, we’ve done mainly SBIRs, but management started to realize that that was not a sustainable way to grow the company. We’ve been pushing for awhile to turn some of our longest-running programs into actual saleable software products. </a:t>
-            </a:r>
-          </a:p>
-          <a:p>
-            <a:r>
-              <a:rPr lang="en-US"/>
-              <a:t>We do a lot with </a:t>
-            </a:r>
-            <a:r>
-              <a:rPr lang="en-US" sz="1200" b="0" i="0" kern="1200">
-                <a:solidFill>
-                  <a:schemeClr val="tx1"/>
-                </a:solidFill>
-                <a:effectLst/>
-                <a:latin typeface="+mn-lt"/>
-                <a:ea typeface="+mn-ea"/>
-                <a:cs typeface="+mn-cs"/>
-              </a:rPr>
-              <a:t>computer vision, with estimation and optimization algorithms; </a:t>
-            </a:r>
-            <a:r>
-              <a:rPr lang="en-US"/>
-              <a:t>a lot of modeling and simulation. </a:t>
-            </a:r>
-          </a:p>
-          <a:p>
-            <a:r>
-              <a:rPr lang="en-US"/>
-              <a:t>We once partnered with a university to design and test a new shape for an airplane wing. (I didn’t see the wing, but the project lead asked me to review the manual and give some feedback.)</a:t>
-            </a:r>
-          </a:p>
-          <a:p>
-            <a:r>
-              <a:rPr lang="en-US"/>
-              <a:t>We’ve worked on developing aircraft collision avoidance systems and non-GPS navigation.</a:t>
+              <a:t>My group is working on autonomy software that allows a mobile robot to perform higher-level tasks. Any soldier who’s piloting a robot is 1</a:t>
+            </a:r>
+            <a:r>
+              <a:rPr lang="en-US" baseline="30000"/>
+              <a:t>st</a:t>
+            </a:r>
+            <a:r>
+              <a:rPr lang="en-US"/>
+              <a:t>) pinning down the squad, which is dangerous; 2</a:t>
+            </a:r>
+            <a:r>
+              <a:rPr lang="en-US" baseline="30000"/>
+              <a:t>nd</a:t>
+            </a:r>
+            <a:r>
+              <a:rPr lang="en-US"/>
+              <a:t>) needs another squad member to protect them while they’re operating the drone; and 3</a:t>
+            </a:r>
+            <a:r>
+              <a:rPr lang="en-US" baseline="30000"/>
+              <a:t>rd</a:t>
+            </a:r>
+            <a:r>
+              <a:rPr lang="en-US"/>
+              <a:t>) those two may need someone protecting them as well. Using a tablet to send the command “go search this area and tell me if you see any people with weapons” is a much safer and more efficient way for a squad of soldiers to do reconnaissance before they enter an area.</a:t>
+            </a:r>
+          </a:p>
+          <a:p>
+            <a:r>
+              <a:rPr lang="en-US"/>
+              <a:t>We’ve partnered with a robotics manufacturer. We’ve just sold 40 systems for evaluation, we’ll be loading their systems with our software. We’ll need to produce documentation, figure out how to do tech support, handle bug tracking and software releases for bug fixes. There’s a lot that has to happen in the next few months to make this all come together, in a company that has never dealt with selling products before. </a:t>
+            </a:r>
+          </a:p>
+          <a:p>
+            <a:r>
+              <a:rPr lang="en-US"/>
+              <a:t>One of my concerns is that we’ve been working with various groups of soldiers field-testing our systems, but we don’t have a good handle yet on WHAT KIND of user documentation they’ll need or want. So far, they basically want to take it out of the box, power it on, and go.</a:t>
             </a:r>
           </a:p>
         </p:txBody>
@@ -1290,7 +1297,7 @@
     </p:spTree>
     <p:extLst>
       <p:ext uri="{BB962C8B-B14F-4D97-AF65-F5344CB8AC3E}">
-        <p14:creationId xmlns:p14="http://schemas.microsoft.com/office/powerpoint/2010/main" val="3235356827"/>
+        <p14:creationId xmlns:p14="http://schemas.microsoft.com/office/powerpoint/2010/main" val="1585632135"/>
       </p:ext>
     </p:extLst>
   </p:cSld>
@@ -1346,43 +1353,21 @@
           <a:p>
             <a:r>
               <a:rPr lang="en-US"/>
-              <a:t>My group is working on autonomy software that allows a mobile robot to perform higher-level tasks. Any soldier who’s piloting a robot is 1</a:t>
-            </a:r>
-            <a:r>
-              <a:rPr lang="en-US" baseline="30000"/>
-              <a:t>st</a:t>
-            </a:r>
-            <a:r>
-              <a:rPr lang="en-US"/>
-              <a:t>) pinning down the squad, which is dangerous; 2</a:t>
-            </a:r>
-            <a:r>
-              <a:rPr lang="en-US" baseline="30000"/>
-              <a:t>nd</a:t>
-            </a:r>
-            <a:r>
-              <a:rPr lang="en-US"/>
-              <a:t>) needs another squad member to protect them while they’re operating the drone; and 3</a:t>
-            </a:r>
-            <a:r>
-              <a:rPr lang="en-US" baseline="30000"/>
-              <a:t>rd</a:t>
-            </a:r>
-            <a:r>
-              <a:rPr lang="en-US"/>
-              <a:t>) those two may need someone protecting them as well. Using a tablet to send the command “go search this area and tell me if you see any people with weapons” is a much safer and more efficient way for a squad of soldiers to do reconnaissance before they enter an area.</a:t>
-            </a:r>
-          </a:p>
-          <a:p>
-            <a:r>
-              <a:rPr lang="en-US"/>
-              <a:t>We’ve partnered with a robotics manufacturer. We’ve just sold 40 systems for evaluation, we’ll be loading their systems with our software. We’ll need to produce documentation, figure out how to do tech support, handle bug tracking and software releases for bug fixes. There’s a lot that has to happen in the next few months to make this all come together, in a company that has never dealt with selling products before. </a:t>
-            </a:r>
-          </a:p>
-          <a:p>
-            <a:r>
-              <a:rPr lang="en-US"/>
-              <a:t>One of my concerns is that we’ve been working with various groups of soldiers field-testing our systems, but we don’t have a good handle yet on WHAT KIND of user documentation they’ll need or want. So far, they basically want to take it out of the box, power it on, and go.</a:t>
+              <a:t>We are already using git (I hate it just as much at work as I did for this course, although had fewer nightmares with merges here.) Our IT department is working on standing up an automation pipeline for our software releases. (At some point we’ll have to figure out how to do over-the-air software updates.) I’m hoping they can set up some doc automation too, once we figure out what we’ll need.</a:t>
+            </a:r>
+          </a:p>
+          <a:p>
+            <a:r>
+              <a:rPr lang="en-US"/>
+              <a:t>I’ve already talked to our tech lead about DITA and </a:t>
+            </a:r>
+            <a:r>
+              <a:rPr lang="en-US" err="1"/>
+              <a:t>OxygenXML</a:t>
+            </a:r>
+            <a:r>
+              <a:rPr lang="en-US"/>
+              <a:t> Editor and Author. Chris had Googled DITA before I finished my second sentence, and was on board right away.</a:t>
             </a:r>
           </a:p>
         </p:txBody>
@@ -1405,107 +1390,6 @@
             <a:fld id="{4DE1F2E9-0273-4734-922D-761DF56606D9}" type="slidenum">
               <a:rPr lang="en-US" smtClean="0"/>
               <a:t>7</a:t>
-            </a:fld>
-            <a:endParaRPr lang="en-US"/>
-          </a:p>
-        </p:txBody>
-      </p:sp>
-    </p:spTree>
-    <p:extLst>
-      <p:ext uri="{BB962C8B-B14F-4D97-AF65-F5344CB8AC3E}">
-        <p14:creationId xmlns:p14="http://schemas.microsoft.com/office/powerpoint/2010/main" val="1585632135"/>
-      </p:ext>
-    </p:extLst>
-  </p:cSld>
-  <p:clrMapOvr>
-    <a:masterClrMapping/>
-  </p:clrMapOvr>
-</p:notes>
-</file>
-
-<file path=ppt/notesSlides/notesSlide8.xml><?xml version="1.0" encoding="utf-8"?>
-<p:notes xmlns:a="http://schemas.openxmlformats.org/drawingml/2006/main" xmlns:r="http://schemas.openxmlformats.org/officeDocument/2006/relationships" xmlns:p="http://schemas.openxmlformats.org/presentationml/2006/main">
-  <p:cSld>
-    <p:spTree>
-      <p:nvGrpSpPr>
-        <p:cNvPr id="1" name=""/>
-        <p:cNvGrpSpPr/>
-        <p:nvPr/>
-      </p:nvGrpSpPr>
-      <p:grpSpPr>
-        <a:xfrm>
-          <a:off x="0" y="0"/>
-          <a:ext cx="0" cy="0"/>
-          <a:chOff x="0" y="0"/>
-          <a:chExt cx="0" cy="0"/>
-        </a:xfrm>
-      </p:grpSpPr>
-      <p:sp>
-        <p:nvSpPr>
-          <p:cNvPr id="2" name="Slide Image Placeholder 1"/>
-          <p:cNvSpPr>
-            <a:spLocks noGrp="1" noRot="1" noChangeAspect="1"/>
-          </p:cNvSpPr>
-          <p:nvPr>
-            <p:ph type="sldImg"/>
-          </p:nvPr>
-        </p:nvSpPr>
-        <p:spPr/>
-      </p:sp>
-      <p:sp>
-        <p:nvSpPr>
-          <p:cNvPr id="3" name="Notes Placeholder 2"/>
-          <p:cNvSpPr>
-            <a:spLocks noGrp="1"/>
-          </p:cNvSpPr>
-          <p:nvPr>
-            <p:ph type="body" idx="1"/>
-          </p:nvPr>
-        </p:nvSpPr>
-        <p:spPr/>
-        <p:txBody>
-          <a:bodyPr/>
-          <a:lstStyle/>
-          <a:p>
-            <a:r>
-              <a:rPr lang="en-US"/>
-              <a:t>We are already using git (I hate it just as much at work as I did for this course, although had fewer nightmares with merges here.) Our IT department is working on standing up an automation pipeline for our software releases. (At some point we’ll have to figure out how to do over-the-air software updates.) I’m hoping they can set up some doc automation too, once we figure out what we’ll need.</a:t>
-            </a:r>
-          </a:p>
-          <a:p>
-            <a:r>
-              <a:rPr lang="en-US"/>
-              <a:t>I’ve already talked to our tech lead about DITA and </a:t>
-            </a:r>
-            <a:r>
-              <a:rPr lang="en-US" err="1"/>
-              <a:t>OxygenXML</a:t>
-            </a:r>
-            <a:r>
-              <a:rPr lang="en-US"/>
-              <a:t> Editor and Author. Chris had Googled DITA before I finished my second sentence, and was on board right away.</a:t>
-            </a:r>
-          </a:p>
-        </p:txBody>
-      </p:sp>
-      <p:sp>
-        <p:nvSpPr>
-          <p:cNvPr id="4" name="Slide Number Placeholder 3"/>
-          <p:cNvSpPr>
-            <a:spLocks noGrp="1"/>
-          </p:cNvSpPr>
-          <p:nvPr>
-            <p:ph type="sldNum" sz="quarter" idx="5"/>
-          </p:nvPr>
-        </p:nvSpPr>
-        <p:spPr/>
-        <p:txBody>
-          <a:bodyPr/>
-          <a:lstStyle/>
-          <a:p>
-            <a:fld id="{4DE1F2E9-0273-4734-922D-761DF56606D9}" type="slidenum">
-              <a:rPr lang="en-US" smtClean="0"/>
-              <a:t>8</a:t>
             </a:fld>
             <a:endParaRPr lang="en-US"/>
           </a:p>
@@ -1524,7 +1408,7 @@
 </p:notes>
 </file>
 
-<file path=ppt/notesSlides/notesSlide9.xml><?xml version="1.0" encoding="utf-8"?>
+<file path=ppt/notesSlides/notesSlide8.xml><?xml version="1.0" encoding="utf-8"?>
 <p:notes xmlns:a="http://schemas.openxmlformats.org/drawingml/2006/main" xmlns:r="http://schemas.openxmlformats.org/officeDocument/2006/relationships" xmlns:p="http://schemas.openxmlformats.org/presentationml/2006/main">
   <p:cSld>
     <p:spTree>
@@ -1630,7 +1514,7 @@
           <a:p>
             <a:fld id="{4DE1F2E9-0273-4734-922D-761DF56606D9}" type="slidenum">
               <a:rPr lang="en-US" smtClean="0"/>
-              <a:t>9</a:t>
+              <a:t>8</a:t>
             </a:fld>
             <a:endParaRPr lang="en-US"/>
           </a:p>
@@ -1640,6 +1524,125 @@
     <p:extLst>
       <p:ext uri="{BB962C8B-B14F-4D97-AF65-F5344CB8AC3E}">
         <p14:creationId xmlns:p14="http://schemas.microsoft.com/office/powerpoint/2010/main" val="455431840"/>
+      </p:ext>
+    </p:extLst>
+  </p:cSld>
+  <p:clrMapOvr>
+    <a:masterClrMapping/>
+  </p:clrMapOvr>
+</p:notes>
+</file>
+
+<file path=ppt/notesSlides/notesSlide9.xml><?xml version="1.0" encoding="utf-8"?>
+<p:notes xmlns:a="http://schemas.openxmlformats.org/drawingml/2006/main" xmlns:r="http://schemas.openxmlformats.org/officeDocument/2006/relationships" xmlns:p="http://schemas.openxmlformats.org/presentationml/2006/main">
+  <p:cSld>
+    <p:spTree>
+      <p:nvGrpSpPr>
+        <p:cNvPr id="1" name=""/>
+        <p:cNvGrpSpPr/>
+        <p:nvPr/>
+      </p:nvGrpSpPr>
+      <p:grpSpPr>
+        <a:xfrm>
+          <a:off x="0" y="0"/>
+          <a:ext cx="0" cy="0"/>
+          <a:chOff x="0" y="0"/>
+          <a:chExt cx="0" cy="0"/>
+        </a:xfrm>
+      </p:grpSpPr>
+      <p:sp>
+        <p:nvSpPr>
+          <p:cNvPr id="2" name="Slide Image Placeholder 1"/>
+          <p:cNvSpPr>
+            <a:spLocks noGrp="1" noRot="1" noChangeAspect="1"/>
+          </p:cNvSpPr>
+          <p:nvPr>
+            <p:ph type="sldImg"/>
+          </p:nvPr>
+        </p:nvSpPr>
+        <p:spPr/>
+      </p:sp>
+      <p:sp>
+        <p:nvSpPr>
+          <p:cNvPr id="3" name="Notes Placeholder 2"/>
+          <p:cNvSpPr>
+            <a:spLocks noGrp="1"/>
+          </p:cNvSpPr>
+          <p:nvPr>
+            <p:ph type="body" idx="1"/>
+          </p:nvPr>
+        </p:nvSpPr>
+        <p:spPr/>
+        <p:txBody>
+          <a:bodyPr/>
+          <a:lstStyle/>
+          <a:p>
+            <a:r>
+              <a:rPr lang="en-US"/>
+              <a:t>I’ve enjoyed learning alongside you all. I wish you all the best in your tech writing careers. </a:t>
+            </a:r>
+          </a:p>
+          <a:p>
+            <a:r>
+              <a:rPr lang="en-US"/>
+              <a:t>Zoe, thank you so much for introducing us to everything we’ve covered these past 15 weeks. I’m going to put some of this information to use in my job fairly quickly, so this course has absolutely been very useful, and I’m grateful for your willingness to share your expertise. </a:t>
+            </a:r>
+          </a:p>
+          <a:p>
+            <a:pPr marL="0" marR="0" lvl="0" indent="0" algn="l" defTabSz="914400" rtl="0" eaLnBrk="1" fontAlgn="auto" latinLnBrk="0" hangingPunct="1">
+              <a:lnSpc>
+                <a:spcPct val="100000"/>
+              </a:lnSpc>
+              <a:spcBef>
+                <a:spcPts val="0"/>
+              </a:spcBef>
+              <a:spcAft>
+                <a:spcPts val="0"/>
+              </a:spcAft>
+              <a:buClrTx/>
+              <a:buSzTx/>
+              <a:buFontTx/>
+              <a:buNone/>
+              <a:tabLst/>
+              <a:defRPr/>
+            </a:pPr>
+            <a:r>
+              <a:rPr lang="en-US"/>
+              <a:t>Any questions?</a:t>
+            </a:r>
+          </a:p>
+          <a:p>
+            <a:endParaRPr lang="en-US"/>
+          </a:p>
+        </p:txBody>
+      </p:sp>
+      <p:sp>
+        <p:nvSpPr>
+          <p:cNvPr id="4" name="Slide Number Placeholder 3"/>
+          <p:cNvSpPr>
+            <a:spLocks noGrp="1"/>
+          </p:cNvSpPr>
+          <p:nvPr>
+            <p:ph type="sldNum" sz="quarter" idx="5"/>
+          </p:nvPr>
+        </p:nvSpPr>
+        <p:spPr/>
+        <p:txBody>
+          <a:bodyPr/>
+          <a:lstStyle/>
+          <a:p>
+            <a:fld id="{4DE1F2E9-0273-4734-922D-761DF56606D9}" type="slidenum">
+              <a:rPr lang="en-US" smtClean="0"/>
+              <a:t>9</a:t>
+            </a:fld>
+            <a:endParaRPr lang="en-US"/>
+          </a:p>
+        </p:txBody>
+      </p:sp>
+    </p:spTree>
+    <p:extLst>
+      <p:ext uri="{BB962C8B-B14F-4D97-AF65-F5344CB8AC3E}">
+        <p14:creationId xmlns:p14="http://schemas.microsoft.com/office/powerpoint/2010/main" val="330846222"/>
       </p:ext>
     </p:extLst>
   </p:cSld>
@@ -1875,7 +1878,7 @@
           <a:p>
             <a:fld id="{76B826DF-62C1-4695-88AE-F7EDEA9EFD19}" type="datetimeFigureOut">
               <a:rPr lang="en-US" smtClean="0"/>
-              <a:t>4/22/2026</a:t>
+              <a:t>5/7/2026</a:t>
             </a:fld>
             <a:endParaRPr lang="en-US"/>
           </a:p>
@@ -2083,7 +2086,7 @@
           <a:p>
             <a:fld id="{76B826DF-62C1-4695-88AE-F7EDEA9EFD19}" type="datetimeFigureOut">
               <a:rPr lang="en-US" smtClean="0"/>
-              <a:t>4/22/2026</a:t>
+              <a:t>5/7/2026</a:t>
             </a:fld>
             <a:endParaRPr lang="en-US"/>
           </a:p>
@@ -2339,7 +2342,7 @@
           <a:p>
             <a:fld id="{76B826DF-62C1-4695-88AE-F7EDEA9EFD19}" type="datetimeFigureOut">
               <a:rPr lang="en-US" smtClean="0"/>
-              <a:t>4/22/2026</a:t>
+              <a:t>5/7/2026</a:t>
             </a:fld>
             <a:endParaRPr lang="en-US"/>
           </a:p>
@@ -2513,7 +2516,7 @@
           <a:p>
             <a:fld id="{76B826DF-62C1-4695-88AE-F7EDEA9EFD19}" type="datetimeFigureOut">
               <a:rPr lang="en-US" smtClean="0"/>
-              <a:t>4/22/2026</a:t>
+              <a:t>5/7/2026</a:t>
             </a:fld>
             <a:endParaRPr lang="en-US"/>
           </a:p>
@@ -2872,7 +2875,7 @@
           <a:p>
             <a:fld id="{76B826DF-62C1-4695-88AE-F7EDEA9EFD19}" type="datetimeFigureOut">
               <a:rPr lang="en-US" smtClean="0"/>
-              <a:t>4/22/2026</a:t>
+              <a:t>5/7/2026</a:t>
             </a:fld>
             <a:endParaRPr lang="en-US"/>
           </a:p>
@@ -3147,7 +3150,7 @@
           <a:p>
             <a:fld id="{76B826DF-62C1-4695-88AE-F7EDEA9EFD19}" type="datetimeFigureOut">
               <a:rPr lang="en-US" smtClean="0"/>
-              <a:t>4/22/2026</a:t>
+              <a:t>5/7/2026</a:t>
             </a:fld>
             <a:endParaRPr lang="en-US"/>
           </a:p>
@@ -3542,7 +3545,7 @@
           <a:p>
             <a:fld id="{76B826DF-62C1-4695-88AE-F7EDEA9EFD19}" type="datetimeFigureOut">
               <a:rPr lang="en-US" smtClean="0"/>
-              <a:t>4/22/2026</a:t>
+              <a:t>5/7/2026</a:t>
             </a:fld>
             <a:endParaRPr lang="en-US"/>
           </a:p>
@@ -3660,7 +3663,7 @@
           <a:p>
             <a:fld id="{76B826DF-62C1-4695-88AE-F7EDEA9EFD19}" type="datetimeFigureOut">
               <a:rPr lang="en-US" smtClean="0"/>
-              <a:t>4/22/2026</a:t>
+              <a:t>5/7/2026</a:t>
             </a:fld>
             <a:endParaRPr lang="en-US"/>
           </a:p>
@@ -3831,7 +3834,7 @@
           <a:p>
             <a:fld id="{76B826DF-62C1-4695-88AE-F7EDEA9EFD19}" type="datetimeFigureOut">
               <a:rPr lang="en-US" smtClean="0"/>
-              <a:t>4/22/2026</a:t>
+              <a:t>5/7/2026</a:t>
             </a:fld>
             <a:endParaRPr lang="en-US"/>
           </a:p>
@@ -4201,7 +4204,7 @@
           <a:p>
             <a:fld id="{76B826DF-62C1-4695-88AE-F7EDEA9EFD19}" type="datetimeFigureOut">
               <a:rPr lang="en-US" smtClean="0"/>
-              <a:t>4/22/2026</a:t>
+              <a:t>5/7/2026</a:t>
             </a:fld>
             <a:endParaRPr lang="en-US"/>
           </a:p>
@@ -4582,7 +4585,7 @@
           <a:p>
             <a:fld id="{76B826DF-62C1-4695-88AE-F7EDEA9EFD19}" type="datetimeFigureOut">
               <a:rPr lang="en-US" smtClean="0"/>
-              <a:t>4/22/2026</a:t>
+              <a:t>5/7/2026</a:t>
             </a:fld>
             <a:endParaRPr lang="en-US"/>
           </a:p>
@@ -4869,7 +4872,7 @@
           <a:p>
             <a:fld id="{76B826DF-62C1-4695-88AE-F7EDEA9EFD19}" type="datetimeFigureOut">
               <a:rPr lang="en-US" smtClean="0"/>
-              <a:t>4/22/2026</a:t>
+              <a:t>5/7/2026</a:t>
             </a:fld>
             <a:endParaRPr lang="en-US"/>
           </a:p>
@@ -5521,7 +5524,7 @@
           <p:cNvPr id="2" name="Title 1">
             <a:extLst>
               <a:ext uri="{FF2B5EF4-FFF2-40B4-BE49-F238E27FC236}">
-                <a16:creationId xmlns:a16="http://schemas.microsoft.com/office/drawing/2014/main" id="{6D397893-5467-F063-33C7-BB2D68FDC312}"/>
+                <a16:creationId xmlns:a16="http://schemas.microsoft.com/office/drawing/2014/main" id="{EFA12C48-9C4F-5734-74A1-99DAF349D080}"/>
               </a:ext>
             </a:extLst>
           </p:cNvPr>
@@ -5534,69 +5537,420 @@
         </p:nvSpPr>
         <p:spPr>
           <a:xfrm>
-            <a:off x="1097280" y="197268"/>
-            <a:ext cx="10058400" cy="702303"/>
-          </a:xfrm>
-        </p:spPr>
-        <p:txBody>
-          <a:bodyPr>
-            <a:normAutofit fontScale="90000"/>
-          </a:bodyPr>
-          <a:lstStyle/>
-          <a:p>
-            <a:r>
-              <a:rPr lang="en-US"/>
-              <a:t>Thank you, and good luck!</a:t>
-            </a:r>
-          </a:p>
-        </p:txBody>
-      </p:sp>
-      <p:sp>
-        <p:nvSpPr>
-          <p:cNvPr id="3" name="Content Placeholder 2">
+            <a:off x="1097280" y="97421"/>
+            <a:ext cx="10058400" cy="737225"/>
+          </a:xfrm>
+        </p:spPr>
+        <p:txBody>
+          <a:bodyPr/>
+          <a:lstStyle/>
+          <a:p>
+            <a:r>
+              <a:rPr lang="en-US"/>
+              <a:t>The US Runs on Small Businesses</a:t>
+            </a:r>
+          </a:p>
+        </p:txBody>
+      </p:sp>
+      <p:pic>
+        <p:nvPicPr>
+          <p:cNvPr id="5" name="Picture 4">
             <a:extLst>
               <a:ext uri="{FF2B5EF4-FFF2-40B4-BE49-F238E27FC236}">
-                <a16:creationId xmlns:a16="http://schemas.microsoft.com/office/drawing/2014/main" id="{77B4E1F4-8F39-9F4A-489D-247931DAE8CC}"/>
+                <a16:creationId xmlns:a16="http://schemas.microsoft.com/office/drawing/2014/main" id="{85F9A45C-4B0E-ED9E-2A43-EF531FF88347}"/>
               </a:ext>
             </a:extLst>
           </p:cNvPr>
-          <p:cNvSpPr>
-            <a:spLocks noGrp="1"/>
-          </p:cNvSpPr>
-          <p:nvPr>
-            <p:ph idx="1"/>
-          </p:nvPr>
-        </p:nvSpPr>
-        <p:spPr>
-          <a:xfrm>
-            <a:off x="1097280" y="1408386"/>
-            <a:ext cx="10058400" cy="4429178"/>
-          </a:xfrm>
-          <a:solidFill>
-            <a:schemeClr val="bg1"/>
-          </a:solidFill>
-        </p:spPr>
-        <p:txBody>
-          <a:bodyPr/>
-          <a:lstStyle/>
-          <a:p>
-            <a:endParaRPr lang="en-US"/>
-          </a:p>
-          <a:p>
-            <a:pPr marL="0" indent="0">
-              <a:buNone/>
-            </a:pPr>
-            <a:r>
-              <a:rPr lang="en-US" sz="4000"/>
-              <a:t>	Questions?</a:t>
-            </a:r>
-          </a:p>
-        </p:txBody>
-      </p:sp>
+          <p:cNvPicPr>
+            <a:picLocks noChangeAspect="1"/>
+          </p:cNvPicPr>
+          <p:nvPr/>
+        </p:nvPicPr>
+        <p:blipFill>
+          <a:blip r:embed="rId3"/>
+          <a:stretch>
+            <a:fillRect/>
+          </a:stretch>
+        </p:blipFill>
+        <p:spPr>
+          <a:xfrm>
+            <a:off x="6364016" y="834646"/>
+            <a:ext cx="5486197" cy="4644695"/>
+          </a:xfrm>
+          <a:prstGeom prst="rect">
+            <a:avLst/>
+          </a:prstGeom>
+        </p:spPr>
+      </p:pic>
+      <p:pic>
+        <p:nvPicPr>
+          <p:cNvPr id="7" name="Picture 6">
+            <a:extLst>
+              <a:ext uri="{FF2B5EF4-FFF2-40B4-BE49-F238E27FC236}">
+                <a16:creationId xmlns:a16="http://schemas.microsoft.com/office/drawing/2014/main" id="{D7955DF7-507C-CFBB-32FA-07C8D189C31E}"/>
+              </a:ext>
+            </a:extLst>
+          </p:cNvPr>
+          <p:cNvPicPr>
+            <a:picLocks noChangeAspect="1"/>
+          </p:cNvPicPr>
+          <p:nvPr/>
+        </p:nvPicPr>
+        <p:blipFill>
+          <a:blip r:embed="rId4"/>
+          <a:stretch>
+            <a:fillRect/>
+          </a:stretch>
+        </p:blipFill>
+        <p:spPr>
+          <a:xfrm>
+            <a:off x="2038479" y="2290987"/>
+            <a:ext cx="2580289" cy="1426951"/>
+          </a:xfrm>
+          <a:prstGeom prst="rect">
+            <a:avLst/>
+          </a:prstGeom>
+        </p:spPr>
+      </p:pic>
+      <p:sp>
+        <p:nvSpPr>
+          <p:cNvPr id="8" name="TextBox 7">
+            <a:extLst>
+              <a:ext uri="{FF2B5EF4-FFF2-40B4-BE49-F238E27FC236}">
+                <a16:creationId xmlns:a16="http://schemas.microsoft.com/office/drawing/2014/main" id="{C69D86C3-523B-A126-3966-5087E98A3FB2}"/>
+              </a:ext>
+            </a:extLst>
+          </p:cNvPr>
+          <p:cNvSpPr txBox="1"/>
+          <p:nvPr/>
+        </p:nvSpPr>
+        <p:spPr>
+          <a:xfrm>
+            <a:off x="1329559" y="5922579"/>
+            <a:ext cx="7855933" cy="369332"/>
+          </a:xfrm>
+          <a:prstGeom prst="rect">
+            <a:avLst/>
+          </a:prstGeom>
+          <a:noFill/>
+        </p:spPr>
+        <p:txBody>
+          <a:bodyPr wrap="none" rtlCol="0">
+            <a:spAutoFit/>
+          </a:bodyPr>
+          <a:lstStyle/>
+          <a:p>
+            <a:r>
+              <a:rPr lang="en-US" b="1">
+                <a:solidFill>
+                  <a:srgbClr val="FF0000"/>
+                </a:solidFill>
+              </a:rPr>
+              <a:t>*</a:t>
+            </a:r>
+            <a:r>
+              <a:rPr lang="en-US"/>
+              <a:t>Source: https://www.uschamber.com/small-business/small-business-data-center</a:t>
+            </a:r>
+          </a:p>
+        </p:txBody>
+      </p:sp>
+      <p:pic>
+        <p:nvPicPr>
+          <p:cNvPr id="11" name="Picture 10">
+            <a:extLst>
+              <a:ext uri="{FF2B5EF4-FFF2-40B4-BE49-F238E27FC236}">
+                <a16:creationId xmlns:a16="http://schemas.microsoft.com/office/drawing/2014/main" id="{3A1BF068-AA42-AE5A-667F-3469FCC2CB7A}"/>
+              </a:ext>
+            </a:extLst>
+          </p:cNvPr>
+          <p:cNvPicPr>
+            <a:picLocks noChangeAspect="1"/>
+          </p:cNvPicPr>
+          <p:nvPr/>
+        </p:nvPicPr>
+        <p:blipFill>
+          <a:blip r:embed="rId5"/>
+          <a:stretch>
+            <a:fillRect/>
+          </a:stretch>
+        </p:blipFill>
+        <p:spPr>
+          <a:xfrm>
+            <a:off x="448417" y="4044930"/>
+            <a:ext cx="5760415" cy="1513711"/>
+          </a:xfrm>
+          <a:prstGeom prst="rect">
+            <a:avLst/>
+          </a:prstGeom>
+        </p:spPr>
+      </p:pic>
+      <p:pic>
+        <p:nvPicPr>
+          <p:cNvPr id="13" name="Picture 12">
+            <a:extLst>
+              <a:ext uri="{FF2B5EF4-FFF2-40B4-BE49-F238E27FC236}">
+                <a16:creationId xmlns:a16="http://schemas.microsoft.com/office/drawing/2014/main" id="{751CB6FF-62ED-192F-0E55-F0C9741E6D66}"/>
+              </a:ext>
+            </a:extLst>
+          </p:cNvPr>
+          <p:cNvPicPr>
+            <a:picLocks noChangeAspect="1"/>
+          </p:cNvPicPr>
+          <p:nvPr/>
+        </p:nvPicPr>
+        <p:blipFill>
+          <a:blip r:embed="rId6"/>
+          <a:stretch>
+            <a:fillRect/>
+          </a:stretch>
+        </p:blipFill>
+        <p:spPr>
+          <a:xfrm>
+            <a:off x="524622" y="945618"/>
+            <a:ext cx="5684210" cy="1018378"/>
+          </a:xfrm>
+          <a:prstGeom prst="rect">
+            <a:avLst/>
+          </a:prstGeom>
+        </p:spPr>
+      </p:pic>
+      <p:sp>
+        <p:nvSpPr>
+          <p:cNvPr id="14" name="TextBox 13">
+            <a:extLst>
+              <a:ext uri="{FF2B5EF4-FFF2-40B4-BE49-F238E27FC236}">
+                <a16:creationId xmlns:a16="http://schemas.microsoft.com/office/drawing/2014/main" id="{33149A03-4320-61F8-2973-888C5DB7176D}"/>
+              </a:ext>
+            </a:extLst>
+          </p:cNvPr>
+          <p:cNvSpPr txBox="1"/>
+          <p:nvPr/>
+        </p:nvSpPr>
+        <p:spPr>
+          <a:xfrm>
+            <a:off x="361712" y="834646"/>
+            <a:ext cx="325820" cy="369332"/>
+          </a:xfrm>
+          <a:prstGeom prst="rect">
+            <a:avLst/>
+          </a:prstGeom>
+          <a:noFill/>
+        </p:spPr>
+        <p:txBody>
+          <a:bodyPr wrap="square" rtlCol="0">
+            <a:spAutoFit/>
+          </a:bodyPr>
+          <a:lstStyle/>
+          <a:p>
+            <a:r>
+              <a:rPr lang="en-US" b="1">
+                <a:solidFill>
+                  <a:srgbClr val="FF0000"/>
+                </a:solidFill>
+              </a:rPr>
+              <a:t>*</a:t>
+            </a:r>
+          </a:p>
+        </p:txBody>
+      </p:sp>
+      <p:sp>
+        <p:nvSpPr>
+          <p:cNvPr id="15" name="TextBox 14">
+            <a:extLst>
+              <a:ext uri="{FF2B5EF4-FFF2-40B4-BE49-F238E27FC236}">
+                <a16:creationId xmlns:a16="http://schemas.microsoft.com/office/drawing/2014/main" id="{14E10CBF-A0D4-2338-4731-B843F66E3A5F}"/>
+              </a:ext>
+            </a:extLst>
+          </p:cNvPr>
+          <p:cNvSpPr txBox="1"/>
+          <p:nvPr/>
+        </p:nvSpPr>
+        <p:spPr>
+          <a:xfrm>
+            <a:off x="1997269" y="2255122"/>
+            <a:ext cx="325820" cy="369332"/>
+          </a:xfrm>
+          <a:prstGeom prst="rect">
+            <a:avLst/>
+          </a:prstGeom>
+          <a:noFill/>
+        </p:spPr>
+        <p:txBody>
+          <a:bodyPr wrap="square" rtlCol="0">
+            <a:spAutoFit/>
+          </a:bodyPr>
+          <a:lstStyle/>
+          <a:p>
+            <a:r>
+              <a:rPr lang="en-US" b="1">
+                <a:solidFill>
+                  <a:srgbClr val="FF0000"/>
+                </a:solidFill>
+              </a:rPr>
+              <a:t>*</a:t>
+            </a:r>
+          </a:p>
+        </p:txBody>
+      </p:sp>
+      <p:sp>
+        <p:nvSpPr>
+          <p:cNvPr id="16" name="TextBox 15">
+            <a:extLst>
+              <a:ext uri="{FF2B5EF4-FFF2-40B4-BE49-F238E27FC236}">
+                <a16:creationId xmlns:a16="http://schemas.microsoft.com/office/drawing/2014/main" id="{B17A2573-C230-E88A-1297-073A9D09206C}"/>
+              </a:ext>
+            </a:extLst>
+          </p:cNvPr>
+          <p:cNvSpPr txBox="1"/>
+          <p:nvPr/>
+        </p:nvSpPr>
+        <p:spPr>
+          <a:xfrm>
+            <a:off x="285507" y="3946391"/>
+            <a:ext cx="325820" cy="369332"/>
+          </a:xfrm>
+          <a:prstGeom prst="rect">
+            <a:avLst/>
+          </a:prstGeom>
+          <a:noFill/>
+        </p:spPr>
+        <p:txBody>
+          <a:bodyPr wrap="square" rtlCol="0">
+            <a:spAutoFit/>
+          </a:bodyPr>
+          <a:lstStyle/>
+          <a:p>
+            <a:r>
+              <a:rPr lang="en-US" b="1">
+                <a:solidFill>
+                  <a:srgbClr val="FF0000"/>
+                </a:solidFill>
+              </a:rPr>
+              <a:t>*</a:t>
+            </a:r>
+          </a:p>
+        </p:txBody>
+      </p:sp>
+      <p:sp>
+        <p:nvSpPr>
+          <p:cNvPr id="17" name="TextBox 16">
+            <a:extLst>
+              <a:ext uri="{FF2B5EF4-FFF2-40B4-BE49-F238E27FC236}">
+                <a16:creationId xmlns:a16="http://schemas.microsoft.com/office/drawing/2014/main" id="{AEDBB946-F3EC-5B06-F97E-69743B3B7E9E}"/>
+              </a:ext>
+            </a:extLst>
+          </p:cNvPr>
+          <p:cNvSpPr txBox="1"/>
+          <p:nvPr/>
+        </p:nvSpPr>
+        <p:spPr>
+          <a:xfrm>
+            <a:off x="6463862" y="908552"/>
+            <a:ext cx="325820" cy="369332"/>
+          </a:xfrm>
+          <a:prstGeom prst="rect">
+            <a:avLst/>
+          </a:prstGeom>
+          <a:noFill/>
+        </p:spPr>
+        <p:txBody>
+          <a:bodyPr wrap="square" rtlCol="0">
+            <a:spAutoFit/>
+          </a:bodyPr>
+          <a:lstStyle/>
+          <a:p>
+            <a:r>
+              <a:rPr lang="en-US" b="1">
+                <a:solidFill>
+                  <a:srgbClr val="FF0000"/>
+                </a:solidFill>
+              </a:rPr>
+              <a:t>*</a:t>
+            </a:r>
+          </a:p>
+        </p:txBody>
+      </p:sp>
+      <p:cxnSp>
+        <p:nvCxnSpPr>
+          <p:cNvPr id="19" name="Straight Connector 18">
+            <a:extLst>
+              <a:ext uri="{FF2B5EF4-FFF2-40B4-BE49-F238E27FC236}">
+                <a16:creationId xmlns:a16="http://schemas.microsoft.com/office/drawing/2014/main" id="{9C7AB50F-5F9E-A05C-4093-06A10DF99BD1}"/>
+              </a:ext>
+            </a:extLst>
+          </p:cNvPr>
+          <p:cNvCxnSpPr/>
+          <p:nvPr/>
+        </p:nvCxnSpPr>
+        <p:spPr>
+          <a:xfrm>
+            <a:off x="1639614" y="5023945"/>
+            <a:ext cx="3468414" cy="0"/>
+          </a:xfrm>
+          <a:prstGeom prst="line">
+            <a:avLst/>
+          </a:prstGeom>
+          <a:ln w="19050"/>
+        </p:spPr>
+        <p:style>
+          <a:lnRef idx="1">
+            <a:schemeClr val="accent1"/>
+          </a:lnRef>
+          <a:fillRef idx="0">
+            <a:schemeClr val="accent1"/>
+          </a:fillRef>
+          <a:effectRef idx="0">
+            <a:schemeClr val="accent1"/>
+          </a:effectRef>
+          <a:fontRef idx="minor">
+            <a:schemeClr val="tx1"/>
+          </a:fontRef>
+        </p:style>
+      </p:cxnSp>
+      <p:cxnSp>
+        <p:nvCxnSpPr>
+          <p:cNvPr id="20" name="Straight Connector 19">
+            <a:extLst>
+              <a:ext uri="{FF2B5EF4-FFF2-40B4-BE49-F238E27FC236}">
+                <a16:creationId xmlns:a16="http://schemas.microsoft.com/office/drawing/2014/main" id="{056A5527-6E05-16E1-4E53-292B4614CE53}"/>
+              </a:ext>
+            </a:extLst>
+          </p:cNvPr>
+          <p:cNvCxnSpPr>
+            <a:cxnSpLocks/>
+          </p:cNvCxnSpPr>
+          <p:nvPr/>
+        </p:nvCxnSpPr>
+        <p:spPr>
+          <a:xfrm>
+            <a:off x="1439920" y="5265680"/>
+            <a:ext cx="2942894" cy="0"/>
+          </a:xfrm>
+          <a:prstGeom prst="line">
+            <a:avLst/>
+          </a:prstGeom>
+          <a:ln w="19050"/>
+        </p:spPr>
+        <p:style>
+          <a:lnRef idx="1">
+            <a:schemeClr val="accent1"/>
+          </a:lnRef>
+          <a:fillRef idx="0">
+            <a:schemeClr val="accent1"/>
+          </a:fillRef>
+          <a:effectRef idx="0">
+            <a:schemeClr val="accent1"/>
+          </a:effectRef>
+          <a:fontRef idx="minor">
+            <a:schemeClr val="tx1"/>
+          </a:fontRef>
+        </p:style>
+      </p:cxnSp>
     </p:spTree>
     <p:extLst>
       <p:ext uri="{BB962C8B-B14F-4D97-AF65-F5344CB8AC3E}">
-        <p14:creationId xmlns:p14="http://schemas.microsoft.com/office/powerpoint/2010/main" val="3801189921"/>
+        <p14:creationId xmlns:p14="http://schemas.microsoft.com/office/powerpoint/2010/main" val="2406531688"/>
       </p:ext>
     </p:extLst>
   </p:cSld>
@@ -6095,10 +6449,10 @@
       </p:grpSpPr>
       <p:sp>
         <p:nvSpPr>
-          <p:cNvPr id="2" name="Title 1">
+          <p:cNvPr id="3" name="Content Placeholder 2">
             <a:extLst>
               <a:ext uri="{FF2B5EF4-FFF2-40B4-BE49-F238E27FC236}">
-                <a16:creationId xmlns:a16="http://schemas.microsoft.com/office/drawing/2014/main" id="{EFA12C48-9C4F-5734-74A1-99DAF349D080}"/>
+                <a16:creationId xmlns:a16="http://schemas.microsoft.com/office/drawing/2014/main" id="{5A18CB18-AD8D-F02F-D9A9-35971C5064FE}"/>
               </a:ext>
             </a:extLst>
           </p:cNvPr>
@@ -6106,62 +6460,91 @@
             <a:spLocks noGrp="1"/>
           </p:cNvSpPr>
           <p:nvPr>
-            <p:ph type="title"/>
-          </p:nvPr>
-        </p:nvSpPr>
-        <p:spPr>
-          <a:xfrm>
-            <a:off x="1097280" y="97421"/>
-            <a:ext cx="10058400" cy="737225"/>
-          </a:xfrm>
-        </p:spPr>
-        <p:txBody>
-          <a:bodyPr/>
-          <a:lstStyle/>
-          <a:p>
-            <a:r>
-              <a:rPr lang="en-US"/>
-              <a:t>The US Runs on Small Businesses</a:t>
-            </a:r>
-          </a:p>
-        </p:txBody>
-      </p:sp>
-      <p:pic>
-        <p:nvPicPr>
-          <p:cNvPr id="5" name="Picture 4">
+            <p:ph idx="1"/>
+          </p:nvPr>
+        </p:nvSpPr>
+        <p:spPr>
+          <a:xfrm>
+            <a:off x="1097280" y="5444358"/>
+            <a:ext cx="10058400" cy="914399"/>
+          </a:xfrm>
+        </p:spPr>
+        <p:txBody>
+          <a:bodyPr>
+            <a:normAutofit fontScale="92500" lnSpcReduction="20000"/>
+          </a:bodyPr>
+          <a:lstStyle/>
+          <a:p>
+            <a:pPr marL="0" indent="0" algn="just">
+              <a:buNone/>
+            </a:pPr>
+            <a:r>
+              <a:rPr lang="en-US"/>
+              <a:t>(All graphics from </a:t>
+            </a:r>
+            <a:r>
+              <a:rPr lang="en-US">
+                <a:hlinkClick r:id="rId3"/>
+              </a:rPr>
+              <a:t>https://www.sbir.gov</a:t>
+            </a:r>
+            <a:r>
+              <a:rPr lang="en-US"/>
+              <a:t>.)</a:t>
+            </a:r>
+          </a:p>
+          <a:p>
+            <a:pPr marL="0" indent="0" algn="just">
+              <a:buNone/>
+            </a:pPr>
+            <a:r>
+              <a:rPr lang="en-US"/>
+              <a:t>Coordinated by the Small Business Administration and funded through participating federal agencies: USDA, DOC, DOD, DOE, ED, HHS [incl’s CDC, FDA, NIH], DHS, DOT, EPA, NASA, NSF</a:t>
+            </a:r>
+          </a:p>
+        </p:txBody>
+      </p:sp>
+      <p:sp>
+        <p:nvSpPr>
+          <p:cNvPr id="8" name="Title 1">
             <a:extLst>
               <a:ext uri="{FF2B5EF4-FFF2-40B4-BE49-F238E27FC236}">
-                <a16:creationId xmlns:a16="http://schemas.microsoft.com/office/drawing/2014/main" id="{85F9A45C-4B0E-ED9E-2A43-EF531FF88347}"/>
+                <a16:creationId xmlns:a16="http://schemas.microsoft.com/office/drawing/2014/main" id="{55D5743F-DE73-4BCC-74B3-95E039A6B9D0}"/>
               </a:ext>
             </a:extLst>
           </p:cNvPr>
-          <p:cNvPicPr>
-            <a:picLocks noChangeAspect="1"/>
-          </p:cNvPicPr>
-          <p:nvPr/>
-        </p:nvPicPr>
-        <p:blipFill>
-          <a:blip r:embed="rId3"/>
-          <a:stretch>
-            <a:fillRect/>
-          </a:stretch>
-        </p:blipFill>
-        <p:spPr>
-          <a:xfrm>
-            <a:off x="6364016" y="834646"/>
-            <a:ext cx="5486197" cy="4644695"/>
-          </a:xfrm>
-          <a:prstGeom prst="rect">
-            <a:avLst/>
-          </a:prstGeom>
-        </p:spPr>
-      </p:pic>
+          <p:cNvSpPr>
+            <a:spLocks noGrp="1"/>
+          </p:cNvSpPr>
+          <p:nvPr>
+            <p:ph type="title"/>
+          </p:nvPr>
+        </p:nvSpPr>
+        <p:spPr>
+          <a:xfrm>
+            <a:off x="1097280" y="70340"/>
+            <a:ext cx="10058400" cy="753626"/>
+          </a:xfrm>
+        </p:spPr>
+        <p:txBody>
+          <a:bodyPr>
+            <a:normAutofit/>
+          </a:bodyPr>
+          <a:lstStyle/>
+          <a:p>
+            <a:r>
+              <a:rPr lang="en-US" sz="4000" b="1"/>
+              <a:t>How (Some) Govt Research Works (cont.)</a:t>
+            </a:r>
+          </a:p>
+        </p:txBody>
+      </p:sp>
       <p:pic>
         <p:nvPicPr>
-          <p:cNvPr id="7" name="Picture 6">
+          <p:cNvPr id="12" name="Picture 11">
             <a:extLst>
               <a:ext uri="{FF2B5EF4-FFF2-40B4-BE49-F238E27FC236}">
-                <a16:creationId xmlns:a16="http://schemas.microsoft.com/office/drawing/2014/main" id="{D7955DF7-507C-CFBB-32FA-07C8D189C31E}"/>
+                <a16:creationId xmlns:a16="http://schemas.microsoft.com/office/drawing/2014/main" id="{9E86BB00-77C1-3246-98CB-D000273FBF95}"/>
               </a:ext>
             </a:extLst>
           </p:cNvPr>
@@ -6178,8 +6561,8 @@
         </p:blipFill>
         <p:spPr>
           <a:xfrm>
-            <a:off x="2038479" y="2290987"/>
-            <a:ext cx="2580289" cy="1426951"/>
+            <a:off x="1512713" y="3254154"/>
+            <a:ext cx="9553353" cy="2133744"/>
           </a:xfrm>
           <a:prstGeom prst="rect">
             <a:avLst/>
@@ -6188,53 +6571,62 @@
       </p:pic>
       <p:sp>
         <p:nvSpPr>
-          <p:cNvPr id="8" name="TextBox 7">
+          <p:cNvPr id="15" name="Rectangle 14">
             <a:extLst>
               <a:ext uri="{FF2B5EF4-FFF2-40B4-BE49-F238E27FC236}">
-                <a16:creationId xmlns:a16="http://schemas.microsoft.com/office/drawing/2014/main" id="{C69D86C3-523B-A126-3966-5087E98A3FB2}"/>
+                <a16:creationId xmlns:a16="http://schemas.microsoft.com/office/drawing/2014/main" id="{03A7A0B8-3465-4F41-6DD0-9FCA4B96AA1F}"/>
               </a:ext>
             </a:extLst>
           </p:cNvPr>
-          <p:cNvSpPr txBox="1"/>
+          <p:cNvSpPr/>
           <p:nvPr/>
         </p:nvSpPr>
         <p:spPr>
           <a:xfrm>
-            <a:off x="1329559" y="5922579"/>
-            <a:ext cx="7855933" cy="369332"/>
+            <a:off x="1008993" y="1550276"/>
+            <a:ext cx="10394731" cy="378372"/>
           </a:xfrm>
           <a:prstGeom prst="rect">
             <a:avLst/>
           </a:prstGeom>
-          <a:noFill/>
-        </p:spPr>
-        <p:txBody>
-          <a:bodyPr wrap="none" rtlCol="0">
-            <a:spAutoFit/>
-          </a:bodyPr>
-          <a:lstStyle/>
-          <a:p>
-            <a:r>
-              <a:rPr lang="en-US" b="1">
-                <a:solidFill>
-                  <a:srgbClr val="FF0000"/>
-                </a:solidFill>
-              </a:rPr>
-              <a:t>*</a:t>
-            </a:r>
-            <a:r>
-              <a:rPr lang="en-US"/>
-              <a:t>Source: https://www.uschamber.com/small-business/small-business-data-center</a:t>
-            </a:r>
+          <a:solidFill>
+            <a:schemeClr val="bg1"/>
+          </a:solidFill>
+          <a:ln>
+            <a:noFill/>
+          </a:ln>
+        </p:spPr>
+        <p:style>
+          <a:lnRef idx="2">
+            <a:schemeClr val="accent1">
+              <a:shade val="15000"/>
+            </a:schemeClr>
+          </a:lnRef>
+          <a:fillRef idx="1">
+            <a:schemeClr val="accent1"/>
+          </a:fillRef>
+          <a:effectRef idx="0">
+            <a:schemeClr val="accent1"/>
+          </a:effectRef>
+          <a:fontRef idx="minor">
+            <a:schemeClr val="lt1"/>
+          </a:fontRef>
+        </p:style>
+        <p:txBody>
+          <a:bodyPr rtlCol="0" anchor="ctr"/>
+          <a:lstStyle/>
+          <a:p>
+            <a:pPr algn="ctr"/>
+            <a:endParaRPr lang="en-US"/>
           </a:p>
         </p:txBody>
       </p:sp>
       <p:pic>
         <p:nvPicPr>
-          <p:cNvPr id="11" name="Picture 10">
+          <p:cNvPr id="17" name="Picture 16">
             <a:extLst>
               <a:ext uri="{FF2B5EF4-FFF2-40B4-BE49-F238E27FC236}">
-                <a16:creationId xmlns:a16="http://schemas.microsoft.com/office/drawing/2014/main" id="{3A1BF068-AA42-AE5A-667F-3469FCC2CB7A}"/>
+                <a16:creationId xmlns:a16="http://schemas.microsoft.com/office/drawing/2014/main" id="{C783C3D3-36A2-0915-05BB-32ED2E613A3B}"/>
               </a:ext>
             </a:extLst>
           </p:cNvPr>
@@ -6251,8 +6643,8 @@
         </p:blipFill>
         <p:spPr>
           <a:xfrm>
-            <a:off x="448417" y="4044930"/>
-            <a:ext cx="5760415" cy="1513711"/>
+            <a:off x="2823864" y="1210530"/>
+            <a:ext cx="1805943" cy="1510741"/>
           </a:xfrm>
           <a:prstGeom prst="rect">
             <a:avLst/>
@@ -6261,10 +6653,10 @@
       </p:pic>
       <p:pic>
         <p:nvPicPr>
-          <p:cNvPr id="13" name="Picture 12">
+          <p:cNvPr id="19" name="Picture 18">
             <a:extLst>
               <a:ext uri="{FF2B5EF4-FFF2-40B4-BE49-F238E27FC236}">
-                <a16:creationId xmlns:a16="http://schemas.microsoft.com/office/drawing/2014/main" id="{751CB6FF-62ED-192F-0E55-F0C9741E6D66}"/>
+                <a16:creationId xmlns:a16="http://schemas.microsoft.com/office/drawing/2014/main" id="{C7CE2AFF-BC57-6BCE-1CDD-5CE5D33F4056}"/>
               </a:ext>
             </a:extLst>
           </p:cNvPr>
@@ -6281,250 +6673,48 @@
         </p:blipFill>
         <p:spPr>
           <a:xfrm>
-            <a:off x="524622" y="945618"/>
-            <a:ext cx="5684210" cy="1018378"/>
+            <a:off x="5155262" y="1152138"/>
+            <a:ext cx="1828923" cy="1569133"/>
           </a:xfrm>
           <a:prstGeom prst="rect">
             <a:avLst/>
           </a:prstGeom>
         </p:spPr>
       </p:pic>
-      <p:sp>
-        <p:nvSpPr>
-          <p:cNvPr id="14" name="TextBox 13">
+      <p:pic>
+        <p:nvPicPr>
+          <p:cNvPr id="21" name="Picture 20">
             <a:extLst>
               <a:ext uri="{FF2B5EF4-FFF2-40B4-BE49-F238E27FC236}">
-                <a16:creationId xmlns:a16="http://schemas.microsoft.com/office/drawing/2014/main" id="{33149A03-4320-61F8-2973-888C5DB7176D}"/>
+                <a16:creationId xmlns:a16="http://schemas.microsoft.com/office/drawing/2014/main" id="{42235689-DE99-E08D-8D36-7EF4FC21C246}"/>
               </a:ext>
             </a:extLst>
           </p:cNvPr>
-          <p:cNvSpPr txBox="1"/>
+          <p:cNvPicPr>
+            <a:picLocks noChangeAspect="1"/>
+          </p:cNvPicPr>
           <p:nvPr/>
-        </p:nvSpPr>
-        <p:spPr>
-          <a:xfrm>
-            <a:off x="361712" y="834646"/>
-            <a:ext cx="325820" cy="369332"/>
+        </p:nvPicPr>
+        <p:blipFill>
+          <a:blip r:embed="rId7"/>
+          <a:stretch>
+            <a:fillRect/>
+          </a:stretch>
+        </p:blipFill>
+        <p:spPr>
+          <a:xfrm>
+            <a:off x="7337405" y="1152138"/>
+            <a:ext cx="2047147" cy="1759646"/>
           </a:xfrm>
           <a:prstGeom prst="rect">
             <a:avLst/>
           </a:prstGeom>
-          <a:noFill/>
-        </p:spPr>
-        <p:txBody>
-          <a:bodyPr wrap="square" rtlCol="0">
-            <a:spAutoFit/>
-          </a:bodyPr>
-          <a:lstStyle/>
-          <a:p>
-            <a:r>
-              <a:rPr lang="en-US" b="1">
-                <a:solidFill>
-                  <a:srgbClr val="FF0000"/>
-                </a:solidFill>
-              </a:rPr>
-              <a:t>*</a:t>
-            </a:r>
-          </a:p>
-        </p:txBody>
-      </p:sp>
-      <p:sp>
-        <p:nvSpPr>
-          <p:cNvPr id="15" name="TextBox 14">
-            <a:extLst>
-              <a:ext uri="{FF2B5EF4-FFF2-40B4-BE49-F238E27FC236}">
-                <a16:creationId xmlns:a16="http://schemas.microsoft.com/office/drawing/2014/main" id="{14E10CBF-A0D4-2338-4731-B843F66E3A5F}"/>
-              </a:ext>
-            </a:extLst>
-          </p:cNvPr>
-          <p:cNvSpPr txBox="1"/>
-          <p:nvPr/>
-        </p:nvSpPr>
-        <p:spPr>
-          <a:xfrm>
-            <a:off x="1997269" y="2255122"/>
-            <a:ext cx="325820" cy="369332"/>
-          </a:xfrm>
-          <a:prstGeom prst="rect">
-            <a:avLst/>
-          </a:prstGeom>
-          <a:noFill/>
-        </p:spPr>
-        <p:txBody>
-          <a:bodyPr wrap="square" rtlCol="0">
-            <a:spAutoFit/>
-          </a:bodyPr>
-          <a:lstStyle/>
-          <a:p>
-            <a:r>
-              <a:rPr lang="en-US" b="1">
-                <a:solidFill>
-                  <a:srgbClr val="FF0000"/>
-                </a:solidFill>
-              </a:rPr>
-              <a:t>*</a:t>
-            </a:r>
-          </a:p>
-        </p:txBody>
-      </p:sp>
-      <p:sp>
-        <p:nvSpPr>
-          <p:cNvPr id="16" name="TextBox 15">
-            <a:extLst>
-              <a:ext uri="{FF2B5EF4-FFF2-40B4-BE49-F238E27FC236}">
-                <a16:creationId xmlns:a16="http://schemas.microsoft.com/office/drawing/2014/main" id="{B17A2573-C230-E88A-1297-073A9D09206C}"/>
-              </a:ext>
-            </a:extLst>
-          </p:cNvPr>
-          <p:cNvSpPr txBox="1"/>
-          <p:nvPr/>
-        </p:nvSpPr>
-        <p:spPr>
-          <a:xfrm>
-            <a:off x="285507" y="3946391"/>
-            <a:ext cx="325820" cy="369332"/>
-          </a:xfrm>
-          <a:prstGeom prst="rect">
-            <a:avLst/>
-          </a:prstGeom>
-          <a:noFill/>
-        </p:spPr>
-        <p:txBody>
-          <a:bodyPr wrap="square" rtlCol="0">
-            <a:spAutoFit/>
-          </a:bodyPr>
-          <a:lstStyle/>
-          <a:p>
-            <a:r>
-              <a:rPr lang="en-US" b="1">
-                <a:solidFill>
-                  <a:srgbClr val="FF0000"/>
-                </a:solidFill>
-              </a:rPr>
-              <a:t>*</a:t>
-            </a:r>
-          </a:p>
-        </p:txBody>
-      </p:sp>
-      <p:sp>
-        <p:nvSpPr>
-          <p:cNvPr id="17" name="TextBox 16">
-            <a:extLst>
-              <a:ext uri="{FF2B5EF4-FFF2-40B4-BE49-F238E27FC236}">
-                <a16:creationId xmlns:a16="http://schemas.microsoft.com/office/drawing/2014/main" id="{AEDBB946-F3EC-5B06-F97E-69743B3B7E9E}"/>
-              </a:ext>
-            </a:extLst>
-          </p:cNvPr>
-          <p:cNvSpPr txBox="1"/>
-          <p:nvPr/>
-        </p:nvSpPr>
-        <p:spPr>
-          <a:xfrm>
-            <a:off x="6463862" y="908552"/>
-            <a:ext cx="325820" cy="369332"/>
-          </a:xfrm>
-          <a:prstGeom prst="rect">
-            <a:avLst/>
-          </a:prstGeom>
-          <a:noFill/>
-        </p:spPr>
-        <p:txBody>
-          <a:bodyPr wrap="square" rtlCol="0">
-            <a:spAutoFit/>
-          </a:bodyPr>
-          <a:lstStyle/>
-          <a:p>
-            <a:r>
-              <a:rPr lang="en-US" b="1">
-                <a:solidFill>
-                  <a:srgbClr val="FF0000"/>
-                </a:solidFill>
-              </a:rPr>
-              <a:t>*</a:t>
-            </a:r>
-          </a:p>
-        </p:txBody>
-      </p:sp>
-      <p:cxnSp>
-        <p:nvCxnSpPr>
-          <p:cNvPr id="19" name="Straight Connector 18">
-            <a:extLst>
-              <a:ext uri="{FF2B5EF4-FFF2-40B4-BE49-F238E27FC236}">
-                <a16:creationId xmlns:a16="http://schemas.microsoft.com/office/drawing/2014/main" id="{9C7AB50F-5F9E-A05C-4093-06A10DF99BD1}"/>
-              </a:ext>
-            </a:extLst>
-          </p:cNvPr>
-          <p:cNvCxnSpPr/>
-          <p:nvPr/>
-        </p:nvCxnSpPr>
-        <p:spPr>
-          <a:xfrm>
-            <a:off x="1639614" y="5023945"/>
-            <a:ext cx="3468414" cy="0"/>
-          </a:xfrm>
-          <a:prstGeom prst="line">
-            <a:avLst/>
-          </a:prstGeom>
-          <a:ln w="19050"/>
-        </p:spPr>
-        <p:style>
-          <a:lnRef idx="1">
-            <a:schemeClr val="accent1"/>
-          </a:lnRef>
-          <a:fillRef idx="0">
-            <a:schemeClr val="accent1"/>
-          </a:fillRef>
-          <a:effectRef idx="0">
-            <a:schemeClr val="accent1"/>
-          </a:effectRef>
-          <a:fontRef idx="minor">
-            <a:schemeClr val="tx1"/>
-          </a:fontRef>
-        </p:style>
-      </p:cxnSp>
-      <p:cxnSp>
-        <p:nvCxnSpPr>
-          <p:cNvPr id="20" name="Straight Connector 19">
-            <a:extLst>
-              <a:ext uri="{FF2B5EF4-FFF2-40B4-BE49-F238E27FC236}">
-                <a16:creationId xmlns:a16="http://schemas.microsoft.com/office/drawing/2014/main" id="{056A5527-6E05-16E1-4E53-292B4614CE53}"/>
-              </a:ext>
-            </a:extLst>
-          </p:cNvPr>
-          <p:cNvCxnSpPr>
-            <a:cxnSpLocks/>
-          </p:cNvCxnSpPr>
-          <p:nvPr/>
-        </p:nvCxnSpPr>
-        <p:spPr>
-          <a:xfrm>
-            <a:off x="1439920" y="5265680"/>
-            <a:ext cx="2942894" cy="0"/>
-          </a:xfrm>
-          <a:prstGeom prst="line">
-            <a:avLst/>
-          </a:prstGeom>
-          <a:ln w="19050"/>
-        </p:spPr>
-        <p:style>
-          <a:lnRef idx="1">
-            <a:schemeClr val="accent1"/>
-          </a:lnRef>
-          <a:fillRef idx="0">
-            <a:schemeClr val="accent1"/>
-          </a:fillRef>
-          <a:effectRef idx="0">
-            <a:schemeClr val="accent1"/>
-          </a:effectRef>
-          <a:fontRef idx="minor">
-            <a:schemeClr val="tx1"/>
-          </a:fontRef>
-        </p:style>
-      </p:cxnSp>
+        </p:spPr>
+      </p:pic>
     </p:spTree>
     <p:extLst>
       <p:ext uri="{BB962C8B-B14F-4D97-AF65-F5344CB8AC3E}">
-        <p14:creationId xmlns:p14="http://schemas.microsoft.com/office/powerpoint/2010/main" val="2406531688"/>
+        <p14:creationId xmlns:p14="http://schemas.microsoft.com/office/powerpoint/2010/main" val="1217969014"/>
       </p:ext>
     </p:extLst>
   </p:cSld>
@@ -6553,10 +6743,45 @@
       </p:grpSpPr>
       <p:sp>
         <p:nvSpPr>
+          <p:cNvPr id="2" name="Title 1">
+            <a:extLst>
+              <a:ext uri="{FF2B5EF4-FFF2-40B4-BE49-F238E27FC236}">
+                <a16:creationId xmlns:a16="http://schemas.microsoft.com/office/drawing/2014/main" id="{13FC4032-CBF8-3BEA-305B-3C7D871E4D21}"/>
+              </a:ext>
+            </a:extLst>
+          </p:cNvPr>
+          <p:cNvSpPr>
+            <a:spLocks noGrp="1"/>
+          </p:cNvSpPr>
+          <p:nvPr>
+            <p:ph type="title"/>
+          </p:nvPr>
+        </p:nvSpPr>
+        <p:spPr>
+          <a:xfrm>
+            <a:off x="1097280" y="1"/>
+            <a:ext cx="10058400" cy="834012"/>
+          </a:xfrm>
+        </p:spPr>
+        <p:txBody>
+          <a:bodyPr>
+            <a:normAutofit/>
+          </a:bodyPr>
+          <a:lstStyle/>
+          <a:p>
+            <a:r>
+              <a:rPr lang="en-US" sz="4000" b="1"/>
+              <a:t>My (Real Life) Documentation Scenario</a:t>
+            </a:r>
+          </a:p>
+        </p:txBody>
+      </p:sp>
+      <p:sp>
+        <p:nvSpPr>
           <p:cNvPr id="3" name="Content Placeholder 2">
             <a:extLst>
               <a:ext uri="{FF2B5EF4-FFF2-40B4-BE49-F238E27FC236}">
-                <a16:creationId xmlns:a16="http://schemas.microsoft.com/office/drawing/2014/main" id="{5A18CB18-AD8D-F02F-D9A9-35971C5064FE}"/>
+                <a16:creationId xmlns:a16="http://schemas.microsoft.com/office/drawing/2014/main" id="{C6D93D9A-89DF-A3DF-24B8-A327E3DEEA01}"/>
               </a:ext>
             </a:extLst>
           </p:cNvPr>
@@ -6569,256 +6794,169 @@
         </p:nvSpPr>
         <p:spPr>
           <a:xfrm>
-            <a:off x="1097280" y="5444358"/>
-            <a:ext cx="10058400" cy="914399"/>
-          </a:xfrm>
+            <a:off x="1097280" y="894479"/>
+            <a:ext cx="10058400" cy="4534117"/>
+          </a:xfrm>
+          <a:solidFill>
+            <a:schemeClr val="bg1"/>
+          </a:solidFill>
         </p:spPr>
         <p:txBody>
           <a:bodyPr>
-            <a:normAutofit fontScale="92500" lnSpcReduction="20000"/>
+            <a:normAutofit fontScale="92500" lnSpcReduction="10000"/>
           </a:bodyPr>
           <a:lstStyle/>
           <a:p>
-            <a:pPr marL="0" indent="0" algn="just">
+            <a:pPr lvl="1">
+              <a:lnSpc>
+                <a:spcPct val="150000"/>
+              </a:lnSpc>
+              <a:buFont typeface="Arial" panose="020B0604020202020204" pitchFamily="34" charset="0"/>
+              <a:buChar char="•"/>
+            </a:pPr>
+            <a:r>
+              <a:rPr lang="en-US" sz="3200"/>
+              <a:t>Small company, founded 1990ish</a:t>
+            </a:r>
+          </a:p>
+          <a:p>
+            <a:pPr lvl="3">
+              <a:lnSpc>
+                <a:spcPct val="110000"/>
+              </a:lnSpc>
+              <a:buFont typeface="Arial" panose="020B0604020202020204" pitchFamily="34" charset="0"/>
+              <a:buChar char="•"/>
+            </a:pPr>
+            <a:r>
+              <a:rPr lang="en-US" sz="2800"/>
+              <a:t>~100 employees; 40% Ph.D.s</a:t>
+            </a:r>
+          </a:p>
+          <a:p>
+            <a:pPr lvl="3">
+              <a:lnSpc>
+                <a:spcPct val="110000"/>
+              </a:lnSpc>
+              <a:buFont typeface="Arial" panose="020B0604020202020204" pitchFamily="34" charset="0"/>
+              <a:buChar char="•"/>
+            </a:pPr>
+            <a:r>
+              <a:rPr lang="en-US" sz="2800"/>
+              <a:t>Has doubled in size since I started there in 2017</a:t>
+            </a:r>
+          </a:p>
+          <a:p>
+            <a:pPr lvl="1">
+              <a:lnSpc>
+                <a:spcPct val="150000"/>
+              </a:lnSpc>
+              <a:buFont typeface="Arial" panose="020B0604020202020204" pitchFamily="34" charset="0"/>
+              <a:buChar char="•"/>
+            </a:pPr>
+            <a:r>
+              <a:rPr lang="en-US" sz="3200"/>
+              <a:t>Does mainly Government research (SBIRs &amp; BAAs*): </a:t>
+            </a:r>
+          </a:p>
+          <a:p>
+            <a:pPr lvl="3">
+              <a:buFont typeface="Arial" panose="020B0604020202020204" pitchFamily="34" charset="0"/>
+              <a:buChar char="•"/>
+            </a:pPr>
+            <a:r>
+              <a:rPr lang="en-US" sz="3200"/>
+              <a:t>Computer vision, w/estimation &amp; optimization algorithms</a:t>
+            </a:r>
+          </a:p>
+          <a:p>
+            <a:pPr lvl="3">
+              <a:buFont typeface="Arial" panose="020B0604020202020204" pitchFamily="34" charset="0"/>
+              <a:buChar char="•"/>
+            </a:pPr>
+            <a:r>
+              <a:rPr lang="en-US" sz="3200"/>
+              <a:t>Software modeling and simulation</a:t>
+            </a:r>
+          </a:p>
+          <a:p>
+            <a:pPr lvl="3">
+              <a:buFont typeface="Arial" panose="020B0604020202020204" pitchFamily="34" charset="0"/>
+              <a:buChar char="•"/>
+            </a:pPr>
+            <a:r>
+              <a:rPr lang="en-US" sz="3200"/>
+              <a:t>Proof of concept projects with robots</a:t>
+            </a:r>
+          </a:p>
+          <a:p>
+            <a:pPr lvl="3">
+              <a:buFont typeface="Arial" panose="020B0604020202020204" pitchFamily="34" charset="0"/>
+              <a:buChar char="•"/>
+            </a:pPr>
+            <a:r>
+              <a:rPr lang="en-US" sz="3200"/>
+              <a:t>Sometimes full prototypes with software</a:t>
+            </a:r>
+          </a:p>
+          <a:p>
+            <a:pPr marL="566928" lvl="3" indent="0">
               <a:buNone/>
             </a:pPr>
-            <a:r>
-              <a:rPr lang="en-US"/>
-              <a:t>(All graphics from </a:t>
-            </a:r>
-            <a:r>
-              <a:rPr lang="en-US">
-                <a:hlinkClick r:id="rId3"/>
-              </a:rPr>
-              <a:t>https://www.sbir.gov</a:t>
-            </a:r>
-            <a:r>
-              <a:rPr lang="en-US"/>
-              <a:t>.)</a:t>
-            </a:r>
-          </a:p>
-          <a:p>
-            <a:pPr marL="0" indent="0" algn="just">
+            <a:endParaRPr lang="en-US" sz="1200"/>
+          </a:p>
+          <a:p>
+            <a:pPr marL="566928" lvl="3" indent="0">
               <a:buNone/>
             </a:pPr>
-            <a:r>
-              <a:rPr lang="en-US"/>
-              <a:t>Coordinated by the Small Business Administration and funded through participating federal agencies: USDA, DOC, DOD, DOE, ED, HHS [incl’s CDC, FDA, NIH], DHS, DOT, EPA, NASA, NSF</a:t>
-            </a:r>
-          </a:p>
-        </p:txBody>
-      </p:sp>
-      <p:sp>
-        <p:nvSpPr>
-          <p:cNvPr id="8" name="Title 1">
+            <a:endParaRPr lang="en-US" sz="3200"/>
+          </a:p>
+          <a:p>
+            <a:pPr marL="0" indent="0">
+              <a:buNone/>
+            </a:pPr>
+            <a:endParaRPr lang="en-US" sz="3200"/>
+          </a:p>
+        </p:txBody>
+      </p:sp>
+      <p:sp>
+        <p:nvSpPr>
+          <p:cNvPr id="4" name="TextBox 3">
             <a:extLst>
               <a:ext uri="{FF2B5EF4-FFF2-40B4-BE49-F238E27FC236}">
-                <a16:creationId xmlns:a16="http://schemas.microsoft.com/office/drawing/2014/main" id="{55D5743F-DE73-4BCC-74B3-95E039A6B9D0}"/>
+                <a16:creationId xmlns:a16="http://schemas.microsoft.com/office/drawing/2014/main" id="{79DBF628-7602-8DE4-2496-A6989A3C9406}"/>
               </a:ext>
             </a:extLst>
           </p:cNvPr>
-          <p:cNvSpPr>
-            <a:spLocks noGrp="1"/>
-          </p:cNvSpPr>
-          <p:nvPr>
-            <p:ph type="title"/>
-          </p:nvPr>
-        </p:nvSpPr>
-        <p:spPr>
-          <a:xfrm>
-            <a:off x="1097280" y="70340"/>
-            <a:ext cx="10058400" cy="753626"/>
-          </a:xfrm>
-        </p:spPr>
-        <p:txBody>
-          <a:bodyPr>
-            <a:normAutofit/>
-          </a:bodyPr>
-          <a:lstStyle/>
-          <a:p>
-            <a:r>
-              <a:rPr lang="en-US" sz="4000" b="1"/>
-              <a:t>How (Some) Govt Research Works (cont.)</a:t>
-            </a:r>
-          </a:p>
-        </p:txBody>
-      </p:sp>
-      <p:pic>
-        <p:nvPicPr>
-          <p:cNvPr id="12" name="Picture 11">
-            <a:extLst>
-              <a:ext uri="{FF2B5EF4-FFF2-40B4-BE49-F238E27FC236}">
-                <a16:creationId xmlns:a16="http://schemas.microsoft.com/office/drawing/2014/main" id="{9E86BB00-77C1-3246-98CB-D000273FBF95}"/>
-              </a:ext>
-            </a:extLst>
-          </p:cNvPr>
-          <p:cNvPicPr>
-            <a:picLocks noChangeAspect="1"/>
-          </p:cNvPicPr>
+          <p:cNvSpPr txBox="1"/>
           <p:nvPr/>
-        </p:nvPicPr>
-        <p:blipFill>
-          <a:blip r:embed="rId4"/>
-          <a:stretch>
-            <a:fillRect/>
-          </a:stretch>
-        </p:blipFill>
-        <p:spPr>
-          <a:xfrm>
-            <a:off x="1512713" y="3254154"/>
-            <a:ext cx="9553353" cy="2133744"/>
+        </p:nvSpPr>
+        <p:spPr>
+          <a:xfrm>
+            <a:off x="1171903" y="5428596"/>
+            <a:ext cx="9983777" cy="923330"/>
           </a:xfrm>
           <a:prstGeom prst="rect">
             <a:avLst/>
           </a:prstGeom>
-        </p:spPr>
-      </p:pic>
-      <p:sp>
-        <p:nvSpPr>
-          <p:cNvPr id="15" name="Rectangle 14">
-            <a:extLst>
-              <a:ext uri="{FF2B5EF4-FFF2-40B4-BE49-F238E27FC236}">
-                <a16:creationId xmlns:a16="http://schemas.microsoft.com/office/drawing/2014/main" id="{03A7A0B8-3465-4F41-6DD0-9FCA4B96AA1F}"/>
-              </a:ext>
-            </a:extLst>
-          </p:cNvPr>
-          <p:cNvSpPr/>
-          <p:nvPr/>
-        </p:nvSpPr>
-        <p:spPr>
-          <a:xfrm>
-            <a:off x="1008993" y="1550276"/>
-            <a:ext cx="10394731" cy="378372"/>
-          </a:xfrm>
-          <a:prstGeom prst="rect">
-            <a:avLst/>
-          </a:prstGeom>
-          <a:solidFill>
-            <a:schemeClr val="bg1"/>
-          </a:solidFill>
-          <a:ln>
-            <a:noFill/>
-          </a:ln>
-        </p:spPr>
-        <p:style>
-          <a:lnRef idx="2">
-            <a:schemeClr val="accent1">
-              <a:shade val="15000"/>
-            </a:schemeClr>
-          </a:lnRef>
-          <a:fillRef idx="1">
-            <a:schemeClr val="accent1"/>
-          </a:fillRef>
-          <a:effectRef idx="0">
-            <a:schemeClr val="accent1"/>
-          </a:effectRef>
-          <a:fontRef idx="minor">
-            <a:schemeClr val="lt1"/>
-          </a:fontRef>
-        </p:style>
-        <p:txBody>
-          <a:bodyPr rtlCol="0" anchor="ctr"/>
-          <a:lstStyle/>
-          <a:p>
-            <a:pPr algn="ctr"/>
-            <a:endParaRPr lang="en-US"/>
-          </a:p>
-        </p:txBody>
-      </p:sp>
-      <p:pic>
-        <p:nvPicPr>
-          <p:cNvPr id="17" name="Picture 16">
-            <a:extLst>
-              <a:ext uri="{FF2B5EF4-FFF2-40B4-BE49-F238E27FC236}">
-                <a16:creationId xmlns:a16="http://schemas.microsoft.com/office/drawing/2014/main" id="{C783C3D3-36A2-0915-05BB-32ED2E613A3B}"/>
-              </a:ext>
-            </a:extLst>
-          </p:cNvPr>
-          <p:cNvPicPr>
-            <a:picLocks noChangeAspect="1"/>
-          </p:cNvPicPr>
-          <p:nvPr/>
-        </p:nvPicPr>
-        <p:blipFill>
-          <a:blip r:embed="rId5"/>
-          <a:stretch>
-            <a:fillRect/>
-          </a:stretch>
-        </p:blipFill>
-        <p:spPr>
-          <a:xfrm>
-            <a:off x="2823864" y="1210530"/>
-            <a:ext cx="1805943" cy="1510741"/>
-          </a:xfrm>
-          <a:prstGeom prst="rect">
-            <a:avLst/>
-          </a:prstGeom>
-        </p:spPr>
-      </p:pic>
-      <p:pic>
-        <p:nvPicPr>
-          <p:cNvPr id="19" name="Picture 18">
-            <a:extLst>
-              <a:ext uri="{FF2B5EF4-FFF2-40B4-BE49-F238E27FC236}">
-                <a16:creationId xmlns:a16="http://schemas.microsoft.com/office/drawing/2014/main" id="{C7CE2AFF-BC57-6BCE-1CDD-5CE5D33F4056}"/>
-              </a:ext>
-            </a:extLst>
-          </p:cNvPr>
-          <p:cNvPicPr>
-            <a:picLocks noChangeAspect="1"/>
-          </p:cNvPicPr>
-          <p:nvPr/>
-        </p:nvPicPr>
-        <p:blipFill>
-          <a:blip r:embed="rId6"/>
-          <a:stretch>
-            <a:fillRect/>
-          </a:stretch>
-        </p:blipFill>
-        <p:spPr>
-          <a:xfrm>
-            <a:off x="5155262" y="1152138"/>
-            <a:ext cx="1828923" cy="1569133"/>
-          </a:xfrm>
-          <a:prstGeom prst="rect">
-            <a:avLst/>
-          </a:prstGeom>
-        </p:spPr>
-      </p:pic>
-      <p:pic>
-        <p:nvPicPr>
-          <p:cNvPr id="21" name="Picture 20">
-            <a:extLst>
-              <a:ext uri="{FF2B5EF4-FFF2-40B4-BE49-F238E27FC236}">
-                <a16:creationId xmlns:a16="http://schemas.microsoft.com/office/drawing/2014/main" id="{42235689-DE99-E08D-8D36-7EF4FC21C246}"/>
-              </a:ext>
-            </a:extLst>
-          </p:cNvPr>
-          <p:cNvPicPr>
-            <a:picLocks noChangeAspect="1"/>
-          </p:cNvPicPr>
-          <p:nvPr/>
-        </p:nvPicPr>
-        <p:blipFill>
-          <a:blip r:embed="rId7"/>
-          <a:stretch>
-            <a:fillRect/>
-          </a:stretch>
-        </p:blipFill>
-        <p:spPr>
-          <a:xfrm>
-            <a:off x="7337405" y="1152138"/>
-            <a:ext cx="2047147" cy="1759646"/>
-          </a:xfrm>
-          <a:prstGeom prst="rect">
-            <a:avLst/>
-          </a:prstGeom>
-        </p:spPr>
-      </p:pic>
+          <a:noFill/>
+        </p:spPr>
+        <p:txBody>
+          <a:bodyPr wrap="square" rtlCol="0">
+            <a:spAutoFit/>
+          </a:bodyPr>
+          <a:lstStyle/>
+          <a:p>
+            <a:r>
+              <a:rPr lang="en-US"/>
+              <a:t>*Broad Agency Announcement; like SBIRs, but lots more $$$/time/staff when you’ve proven you can manage smaller programs, and you’ve developed a good commercial &amp; Govt network in your specific research area. </a:t>
+            </a:r>
+          </a:p>
+        </p:txBody>
+      </p:sp>
     </p:spTree>
     <p:extLst>
       <p:ext uri="{BB962C8B-B14F-4D97-AF65-F5344CB8AC3E}">
-        <p14:creationId xmlns:p14="http://schemas.microsoft.com/office/powerpoint/2010/main" val="1217969014"/>
+        <p14:creationId xmlns:p14="http://schemas.microsoft.com/office/powerpoint/2010/main" val="2012724092"/>
       </p:ext>
     </p:extLst>
   </p:cSld>
@@ -6850,7 +6988,7 @@
           <p:cNvPr id="2" name="Title 1">
             <a:extLst>
               <a:ext uri="{FF2B5EF4-FFF2-40B4-BE49-F238E27FC236}">
-                <a16:creationId xmlns:a16="http://schemas.microsoft.com/office/drawing/2014/main" id="{13FC4032-CBF8-3BEA-305B-3C7D871E4D21}"/>
+                <a16:creationId xmlns:a16="http://schemas.microsoft.com/office/drawing/2014/main" id="{58C97EC9-2E1E-25FF-C73E-4DF867B53614}"/>
               </a:ext>
             </a:extLst>
           </p:cNvPr>
@@ -6864,7 +7002,7 @@
         <p:spPr>
           <a:xfrm>
             <a:off x="1097280" y="1"/>
-            <a:ext cx="10058400" cy="834012"/>
+            <a:ext cx="10058400" cy="678263"/>
           </a:xfrm>
         </p:spPr>
         <p:txBody>
@@ -6874,8 +7012,8 @@
           <a:lstStyle/>
           <a:p>
             <a:r>
-              <a:rPr lang="en-US" sz="4000" b="1"/>
-              <a:t>My (Real Life) Documentation Scenario</a:t>
+              <a:rPr lang="en-US" sz="4000"/>
+              <a:t>Documentation Scenario (cont.)</a:t>
             </a:r>
           </a:p>
         </p:txBody>
@@ -6885,7 +7023,7 @@
           <p:cNvPr id="3" name="Content Placeholder 2">
             <a:extLst>
               <a:ext uri="{FF2B5EF4-FFF2-40B4-BE49-F238E27FC236}">
-                <a16:creationId xmlns:a16="http://schemas.microsoft.com/office/drawing/2014/main" id="{C6D93D9A-89DF-A3DF-24B8-A327E3DEEA01}"/>
+                <a16:creationId xmlns:a16="http://schemas.microsoft.com/office/drawing/2014/main" id="{EB153B4D-B962-3C8A-93C5-5501199CFCF6}"/>
               </a:ext>
             </a:extLst>
           </p:cNvPr>
@@ -6898,8 +7036,8 @@
         </p:nvSpPr>
         <p:spPr>
           <a:xfrm>
-            <a:off x="1097280" y="894479"/>
-            <a:ext cx="10058400" cy="4534117"/>
+            <a:off x="1097279" y="767255"/>
+            <a:ext cx="10306445" cy="4970460"/>
           </a:xfrm>
           <a:solidFill>
             <a:schemeClr val="bg1"/>
@@ -6907,118 +7045,84 @@
         </p:spPr>
         <p:txBody>
           <a:bodyPr>
-            <a:normAutofit fontScale="92500" lnSpcReduction="10000"/>
+            <a:normAutofit/>
           </a:bodyPr>
           <a:lstStyle/>
           <a:p>
-            <a:pPr lvl="1">
-              <a:lnSpc>
-                <a:spcPct val="150000"/>
-              </a:lnSpc>
+            <a:pPr>
               <a:buFont typeface="Arial" panose="020B0604020202020204" pitchFamily="34" charset="0"/>
               <a:buChar char="•"/>
             </a:pPr>
             <a:r>
-              <a:rPr lang="en-US" sz="3200"/>
-              <a:t>Small company, founded 1990ish</a:t>
-            </a:r>
-          </a:p>
-          <a:p>
-            <a:pPr lvl="3">
-              <a:lnSpc>
-                <a:spcPct val="110000"/>
-              </a:lnSpc>
+              <a:rPr lang="en-US" sz="2800"/>
+              <a:t> My group has developed autonomy software that allows a mobile robot to perform higher-level tasks that would otherwise need human supervision. (These are mainly robots being used by the Army.)</a:t>
+            </a:r>
+          </a:p>
+          <a:p>
+            <a:pPr>
               <a:buFont typeface="Arial" panose="020B0604020202020204" pitchFamily="34" charset="0"/>
               <a:buChar char="•"/>
             </a:pPr>
             <a:r>
               <a:rPr lang="en-US" sz="2800"/>
-              <a:t>~100 employees; 40% Ph.D.s</a:t>
-            </a:r>
-          </a:p>
-          <a:p>
-            <a:pPr lvl="3">
-              <a:lnSpc>
-                <a:spcPct val="110000"/>
-              </a:lnSpc>
+              <a:t> Software is close to being a minimum viable product (MVP)</a:t>
+            </a:r>
+          </a:p>
+          <a:p>
+            <a:pPr>
               <a:buFont typeface="Arial" panose="020B0604020202020204" pitchFamily="34" charset="0"/>
               <a:buChar char="•"/>
             </a:pPr>
             <a:r>
               <a:rPr lang="en-US" sz="2800"/>
-              <a:t>Has doubled in size since I started there in 2017</a:t>
-            </a:r>
-          </a:p>
-          <a:p>
-            <a:pPr lvl="1">
-              <a:lnSpc>
-                <a:spcPct val="150000"/>
-              </a:lnSpc>
+              <a:t> Have received an order for 40+ units – hardware with software licenses – for evaluation</a:t>
+            </a:r>
+          </a:p>
+          <a:p>
+            <a:pPr>
               <a:buFont typeface="Arial" panose="020B0604020202020204" pitchFamily="34" charset="0"/>
               <a:buChar char="•"/>
             </a:pPr>
             <a:r>
-              <a:rPr lang="en-US" sz="3200"/>
-              <a:t>Does mainly Government research (SBIRs &amp; BAAs*): </a:t>
-            </a:r>
-          </a:p>
-          <a:p>
-            <a:pPr lvl="3">
+              <a:rPr lang="en-US" sz="2800"/>
+              <a:t> Need to produce (minimum): safety documentation, etc.</a:t>
+            </a:r>
+          </a:p>
+          <a:p>
+            <a:pPr>
               <a:buFont typeface="Arial" panose="020B0604020202020204" pitchFamily="34" charset="0"/>
               <a:buChar char="•"/>
             </a:pPr>
             <a:r>
-              <a:rPr lang="en-US" sz="3200"/>
-              <a:t>Computer vision, w/estimation &amp; optimization algorithms</a:t>
-            </a:r>
-          </a:p>
-          <a:p>
-            <a:pPr lvl="3">
+              <a:rPr lang="en-US" sz="2800"/>
+              <a:t> May need (</a:t>
+            </a:r>
+            <a:r>
+              <a:rPr lang="en-US" sz="2800" b="1"/>
+              <a:t>???</a:t>
+            </a:r>
+            <a:r>
+              <a:rPr lang="en-US" sz="2800"/>
+              <a:t>): training materials, user guides, reference guides</a:t>
+            </a:r>
+          </a:p>
+          <a:p>
+            <a:pPr>
               <a:buFont typeface="Arial" panose="020B0604020202020204" pitchFamily="34" charset="0"/>
               <a:buChar char="•"/>
             </a:pPr>
             <a:r>
-              <a:rPr lang="en-US" sz="3200"/>
-              <a:t>Software modeling and simulation</a:t>
-            </a:r>
-          </a:p>
-          <a:p>
-            <a:pPr lvl="3">
+              <a:rPr lang="en-US" sz="2800"/>
+              <a:t> 1 technical writer*</a:t>
+            </a:r>
+            <a:endParaRPr lang="en-US" sz="3200" baseline="30000"/>
+          </a:p>
+          <a:p>
+            <a:pPr>
               <a:buFont typeface="Arial" panose="020B0604020202020204" pitchFamily="34" charset="0"/>
               <a:buChar char="•"/>
             </a:pPr>
-            <a:r>
-              <a:rPr lang="en-US" sz="3200"/>
-              <a:t>Proof of concept projects with robots</a:t>
-            </a:r>
-          </a:p>
-          <a:p>
-            <a:pPr lvl="3">
-              <a:buFont typeface="Arial" panose="020B0604020202020204" pitchFamily="34" charset="0"/>
-              <a:buChar char="•"/>
-            </a:pPr>
-            <a:r>
-              <a:rPr lang="en-US" sz="3200"/>
-              <a:t>Sometimes full prototypes with software</a:t>
-            </a:r>
-          </a:p>
-          <a:p>
-            <a:pPr marL="566928" lvl="3" indent="0">
-              <a:buNone/>
-            </a:pPr>
-            <a:endParaRPr lang="en-US" sz="1200"/>
-          </a:p>
-          <a:p>
-            <a:pPr marL="566928" lvl="3" indent="0">
-              <a:buNone/>
-            </a:pPr>
-            <a:endParaRPr lang="en-US" sz="3200"/>
-          </a:p>
-          <a:p>
-            <a:pPr marL="0" indent="0">
-              <a:buNone/>
-            </a:pPr>
-            <a:endParaRPr lang="en-US" sz="3200"/>
+            <a:endParaRPr lang="en-US" sz="2800"/>
           </a:p>
         </p:txBody>
       </p:sp>
@@ -7027,7 +7131,7 @@
           <p:cNvPr id="4" name="TextBox 3">
             <a:extLst>
               <a:ext uri="{FF2B5EF4-FFF2-40B4-BE49-F238E27FC236}">
-                <a16:creationId xmlns:a16="http://schemas.microsoft.com/office/drawing/2014/main" id="{79DBF628-7602-8DE4-2496-A6989A3C9406}"/>
+                <a16:creationId xmlns:a16="http://schemas.microsoft.com/office/drawing/2014/main" id="{4DB930E1-611D-4A4B-6662-67B8FDAF6319}"/>
               </a:ext>
             </a:extLst>
           </p:cNvPr>
@@ -7036,8 +7140,8 @@
         </p:nvSpPr>
         <p:spPr>
           <a:xfrm>
-            <a:off x="1171903" y="5428596"/>
-            <a:ext cx="9983777" cy="923330"/>
+            <a:off x="1151934" y="5699261"/>
+            <a:ext cx="9942786" cy="646331"/>
           </a:xfrm>
           <a:prstGeom prst="rect">
             <a:avLst/>
@@ -7052,7 +7156,7 @@
           <a:p>
             <a:r>
               <a:rPr lang="en-US"/>
-              <a:t>*Broad Agency Announcement; like SBIRs, but lots more $$$/time/staff when you’ve proven you can manage smaller programs, and you’ve developed a good commercial &amp; Govt network in your specific research area. </a:t>
+              <a:t>*Research engineers are usually good writers, but they’re mainly academics, which is a different kind of writing.</a:t>
             </a:r>
           </a:p>
         </p:txBody>
@@ -7060,7 +7164,7 @@
     </p:spTree>
     <p:extLst>
       <p:ext uri="{BB962C8B-B14F-4D97-AF65-F5344CB8AC3E}">
-        <p14:creationId xmlns:p14="http://schemas.microsoft.com/office/powerpoint/2010/main" val="2012724092"/>
+        <p14:creationId xmlns:p14="http://schemas.microsoft.com/office/powerpoint/2010/main" val="734411142"/>
       </p:ext>
     </p:extLst>
   </p:cSld>
@@ -7089,214 +7193,6 @@
       </p:grpSpPr>
       <p:sp>
         <p:nvSpPr>
-          <p:cNvPr id="2" name="Title 1">
-            <a:extLst>
-              <a:ext uri="{FF2B5EF4-FFF2-40B4-BE49-F238E27FC236}">
-                <a16:creationId xmlns:a16="http://schemas.microsoft.com/office/drawing/2014/main" id="{58C97EC9-2E1E-25FF-C73E-4DF867B53614}"/>
-              </a:ext>
-            </a:extLst>
-          </p:cNvPr>
-          <p:cNvSpPr>
-            <a:spLocks noGrp="1"/>
-          </p:cNvSpPr>
-          <p:nvPr>
-            <p:ph type="title"/>
-          </p:nvPr>
-        </p:nvSpPr>
-        <p:spPr>
-          <a:xfrm>
-            <a:off x="1097280" y="1"/>
-            <a:ext cx="10058400" cy="678263"/>
-          </a:xfrm>
-        </p:spPr>
-        <p:txBody>
-          <a:bodyPr>
-            <a:normAutofit/>
-          </a:bodyPr>
-          <a:lstStyle/>
-          <a:p>
-            <a:r>
-              <a:rPr lang="en-US" sz="4000"/>
-              <a:t>Documentation Scenario (cont.)</a:t>
-            </a:r>
-          </a:p>
-        </p:txBody>
-      </p:sp>
-      <p:sp>
-        <p:nvSpPr>
-          <p:cNvPr id="3" name="Content Placeholder 2">
-            <a:extLst>
-              <a:ext uri="{FF2B5EF4-FFF2-40B4-BE49-F238E27FC236}">
-                <a16:creationId xmlns:a16="http://schemas.microsoft.com/office/drawing/2014/main" id="{EB153B4D-B962-3C8A-93C5-5501199CFCF6}"/>
-              </a:ext>
-            </a:extLst>
-          </p:cNvPr>
-          <p:cNvSpPr>
-            <a:spLocks noGrp="1"/>
-          </p:cNvSpPr>
-          <p:nvPr>
-            <p:ph idx="1"/>
-          </p:nvPr>
-        </p:nvSpPr>
-        <p:spPr>
-          <a:xfrm>
-            <a:off x="1097279" y="767255"/>
-            <a:ext cx="10306445" cy="4970460"/>
-          </a:xfrm>
-          <a:solidFill>
-            <a:schemeClr val="bg1"/>
-          </a:solidFill>
-        </p:spPr>
-        <p:txBody>
-          <a:bodyPr>
-            <a:normAutofit/>
-          </a:bodyPr>
-          <a:lstStyle/>
-          <a:p>
-            <a:pPr>
-              <a:buFont typeface="Arial" panose="020B0604020202020204" pitchFamily="34" charset="0"/>
-              <a:buChar char="•"/>
-            </a:pPr>
-            <a:r>
-              <a:rPr lang="en-US" sz="2800"/>
-              <a:t> My group has developed autonomy software that allows a mobile robot to perform higher-level tasks that would otherwise need human supervision. (These are mainly robots being used by the Army.)</a:t>
-            </a:r>
-          </a:p>
-          <a:p>
-            <a:pPr>
-              <a:buFont typeface="Arial" panose="020B0604020202020204" pitchFamily="34" charset="0"/>
-              <a:buChar char="•"/>
-            </a:pPr>
-            <a:r>
-              <a:rPr lang="en-US" sz="2800"/>
-              <a:t> Software is close to being a minimum viable product (MVP)</a:t>
-            </a:r>
-          </a:p>
-          <a:p>
-            <a:pPr>
-              <a:buFont typeface="Arial" panose="020B0604020202020204" pitchFamily="34" charset="0"/>
-              <a:buChar char="•"/>
-            </a:pPr>
-            <a:r>
-              <a:rPr lang="en-US" sz="2800"/>
-              <a:t> Have received an order for 40+ units – hardware with software licenses – for evaluation</a:t>
-            </a:r>
-          </a:p>
-          <a:p>
-            <a:pPr>
-              <a:buFont typeface="Arial" panose="020B0604020202020204" pitchFamily="34" charset="0"/>
-              <a:buChar char="•"/>
-            </a:pPr>
-            <a:r>
-              <a:rPr lang="en-US" sz="2800"/>
-              <a:t> Need to produce (minimum): safety documentation, etc.</a:t>
-            </a:r>
-          </a:p>
-          <a:p>
-            <a:pPr>
-              <a:buFont typeface="Arial" panose="020B0604020202020204" pitchFamily="34" charset="0"/>
-              <a:buChar char="•"/>
-            </a:pPr>
-            <a:r>
-              <a:rPr lang="en-US" sz="2800"/>
-              <a:t> May need (</a:t>
-            </a:r>
-            <a:r>
-              <a:rPr lang="en-US" sz="2800" b="1"/>
-              <a:t>???</a:t>
-            </a:r>
-            <a:r>
-              <a:rPr lang="en-US" sz="2800"/>
-              <a:t>): training materials, user guides, reference guides</a:t>
-            </a:r>
-          </a:p>
-          <a:p>
-            <a:pPr>
-              <a:buFont typeface="Arial" panose="020B0604020202020204" pitchFamily="34" charset="0"/>
-              <a:buChar char="•"/>
-            </a:pPr>
-            <a:r>
-              <a:rPr lang="en-US" sz="2800"/>
-              <a:t> 1 technical writer*</a:t>
-            </a:r>
-            <a:endParaRPr lang="en-US" sz="3200" baseline="30000"/>
-          </a:p>
-          <a:p>
-            <a:pPr>
-              <a:buFont typeface="Arial" panose="020B0604020202020204" pitchFamily="34" charset="0"/>
-              <a:buChar char="•"/>
-            </a:pPr>
-            <a:endParaRPr lang="en-US" sz="2800"/>
-          </a:p>
-        </p:txBody>
-      </p:sp>
-      <p:sp>
-        <p:nvSpPr>
-          <p:cNvPr id="4" name="TextBox 3">
-            <a:extLst>
-              <a:ext uri="{FF2B5EF4-FFF2-40B4-BE49-F238E27FC236}">
-                <a16:creationId xmlns:a16="http://schemas.microsoft.com/office/drawing/2014/main" id="{4DB930E1-611D-4A4B-6662-67B8FDAF6319}"/>
-              </a:ext>
-            </a:extLst>
-          </p:cNvPr>
-          <p:cNvSpPr txBox="1"/>
-          <p:nvPr/>
-        </p:nvSpPr>
-        <p:spPr>
-          <a:xfrm>
-            <a:off x="1151934" y="5699261"/>
-            <a:ext cx="9942786" cy="646331"/>
-          </a:xfrm>
-          <a:prstGeom prst="rect">
-            <a:avLst/>
-          </a:prstGeom>
-          <a:noFill/>
-        </p:spPr>
-        <p:txBody>
-          <a:bodyPr wrap="square" rtlCol="0">
-            <a:spAutoFit/>
-          </a:bodyPr>
-          <a:lstStyle/>
-          <a:p>
-            <a:r>
-              <a:rPr lang="en-US"/>
-              <a:t>*Research engineers are usually good writers, but they’re mainly academics, which is a different kind of writing.</a:t>
-            </a:r>
-          </a:p>
-        </p:txBody>
-      </p:sp>
-    </p:spTree>
-    <p:extLst>
-      <p:ext uri="{BB962C8B-B14F-4D97-AF65-F5344CB8AC3E}">
-        <p14:creationId xmlns:p14="http://schemas.microsoft.com/office/powerpoint/2010/main" val="734411142"/>
-      </p:ext>
-    </p:extLst>
-  </p:cSld>
-  <p:clrMapOvr>
-    <a:masterClrMapping/>
-  </p:clrMapOvr>
-</p:sld>
-</file>
-
-<file path=ppt/slides/slide8.xml><?xml version="1.0" encoding="utf-8"?>
-<p:sld xmlns:a="http://schemas.openxmlformats.org/drawingml/2006/main" xmlns:r="http://schemas.openxmlformats.org/officeDocument/2006/relationships" xmlns:p="http://schemas.openxmlformats.org/presentationml/2006/main">
-  <p:cSld>
-    <p:spTree>
-      <p:nvGrpSpPr>
-        <p:cNvPr id="1" name=""/>
-        <p:cNvGrpSpPr/>
-        <p:nvPr/>
-      </p:nvGrpSpPr>
-      <p:grpSpPr>
-        <a:xfrm>
-          <a:off x="0" y="0"/>
-          <a:ext cx="0" cy="0"/>
-          <a:chOff x="0" y="0"/>
-          <a:chExt cx="0" cy="0"/>
-        </a:xfrm>
-      </p:grpSpPr>
-      <p:sp>
-        <p:nvSpPr>
           <p:cNvPr id="3" name="Content Placeholder 2">
             <a:extLst>
               <a:ext uri="{FF2B5EF4-FFF2-40B4-BE49-F238E27FC236}">
@@ -7457,7 +7353,7 @@
 </p:sld>
 </file>
 
-<file path=ppt/slides/slide9.xml><?xml version="1.0" encoding="utf-8"?>
+<file path=ppt/slides/slide8.xml><?xml version="1.0" encoding="utf-8"?>
 <p:sld xmlns:a="http://schemas.openxmlformats.org/drawingml/2006/main" xmlns:r="http://schemas.openxmlformats.org/officeDocument/2006/relationships" xmlns:p="http://schemas.openxmlformats.org/presentationml/2006/main">
   <p:cSld>
     <p:spTree>
@@ -7680,6 +7576,113 @@
     <p:extLst>
       <p:ext uri="{BB962C8B-B14F-4D97-AF65-F5344CB8AC3E}">
         <p14:creationId xmlns:p14="http://schemas.microsoft.com/office/powerpoint/2010/main" val="770979936"/>
+      </p:ext>
+    </p:extLst>
+  </p:cSld>
+  <p:clrMapOvr>
+    <a:masterClrMapping/>
+  </p:clrMapOvr>
+</p:sld>
+</file>
+
+<file path=ppt/slides/slide9.xml><?xml version="1.0" encoding="utf-8"?>
+<p:sld xmlns:a="http://schemas.openxmlformats.org/drawingml/2006/main" xmlns:r="http://schemas.openxmlformats.org/officeDocument/2006/relationships" xmlns:p="http://schemas.openxmlformats.org/presentationml/2006/main">
+  <p:cSld>
+    <p:spTree>
+      <p:nvGrpSpPr>
+        <p:cNvPr id="1" name=""/>
+        <p:cNvGrpSpPr/>
+        <p:nvPr/>
+      </p:nvGrpSpPr>
+      <p:grpSpPr>
+        <a:xfrm>
+          <a:off x="0" y="0"/>
+          <a:ext cx="0" cy="0"/>
+          <a:chOff x="0" y="0"/>
+          <a:chExt cx="0" cy="0"/>
+        </a:xfrm>
+      </p:grpSpPr>
+      <p:sp>
+        <p:nvSpPr>
+          <p:cNvPr id="2" name="Title 1">
+            <a:extLst>
+              <a:ext uri="{FF2B5EF4-FFF2-40B4-BE49-F238E27FC236}">
+                <a16:creationId xmlns:a16="http://schemas.microsoft.com/office/drawing/2014/main" id="{6D397893-5467-F063-33C7-BB2D68FDC312}"/>
+              </a:ext>
+            </a:extLst>
+          </p:cNvPr>
+          <p:cNvSpPr>
+            <a:spLocks noGrp="1"/>
+          </p:cNvSpPr>
+          <p:nvPr>
+            <p:ph type="title"/>
+          </p:nvPr>
+        </p:nvSpPr>
+        <p:spPr>
+          <a:xfrm>
+            <a:off x="1097280" y="197268"/>
+            <a:ext cx="10058400" cy="702303"/>
+          </a:xfrm>
+        </p:spPr>
+        <p:txBody>
+          <a:bodyPr>
+            <a:normAutofit fontScale="90000"/>
+          </a:bodyPr>
+          <a:lstStyle/>
+          <a:p>
+            <a:r>
+              <a:rPr lang="en-US"/>
+              <a:t>Thank you, and good luck!</a:t>
+            </a:r>
+          </a:p>
+        </p:txBody>
+      </p:sp>
+      <p:sp>
+        <p:nvSpPr>
+          <p:cNvPr id="3" name="Content Placeholder 2">
+            <a:extLst>
+              <a:ext uri="{FF2B5EF4-FFF2-40B4-BE49-F238E27FC236}">
+                <a16:creationId xmlns:a16="http://schemas.microsoft.com/office/drawing/2014/main" id="{77B4E1F4-8F39-9F4A-489D-247931DAE8CC}"/>
+              </a:ext>
+            </a:extLst>
+          </p:cNvPr>
+          <p:cNvSpPr>
+            <a:spLocks noGrp="1"/>
+          </p:cNvSpPr>
+          <p:nvPr>
+            <p:ph idx="1"/>
+          </p:nvPr>
+        </p:nvSpPr>
+        <p:spPr>
+          <a:xfrm>
+            <a:off x="1097280" y="1408386"/>
+            <a:ext cx="10058400" cy="4429178"/>
+          </a:xfrm>
+          <a:solidFill>
+            <a:schemeClr val="bg1"/>
+          </a:solidFill>
+        </p:spPr>
+        <p:txBody>
+          <a:bodyPr/>
+          <a:lstStyle/>
+          <a:p>
+            <a:endParaRPr lang="en-US"/>
+          </a:p>
+          <a:p>
+            <a:pPr marL="0" indent="0">
+              <a:buNone/>
+            </a:pPr>
+            <a:r>
+              <a:rPr lang="en-US" sz="4000"/>
+              <a:t>	Questions?</a:t>
+            </a:r>
+          </a:p>
+        </p:txBody>
+      </p:sp>
+    </p:spTree>
+    <p:extLst>
+      <p:ext uri="{BB962C8B-B14F-4D97-AF65-F5344CB8AC3E}">
+        <p14:creationId xmlns:p14="http://schemas.microsoft.com/office/powerpoint/2010/main" val="3801189921"/>
       </p:ext>
     </p:extLst>
   </p:cSld>

</xml_diff>